<commit_message>
make sure updated before presetation
</commit_message>
<xml_diff>
--- a/Architect-Dev-Presentation.pptx
+++ b/Architect-Dev-Presentation.pptx
@@ -513,7 +513,7 @@
           <a:p>
             <a:r>
               <a:rPr lang="en-US" dirty="0"/>
-              <a:t>Opening (≈45s). Hi — I'm Manfred. I'm going to walk you through Architect.Dev, a portfolio platform I built, with a focus on the technologies I used and how they fit together. I'll stay at an architecture level — no code walkthrough — but by the end you should have a clear mental model of what talks to what and why I picked each piece.</a:t>
+              <a:t/>
             </a:r>
             <a:endParaRPr lang="en-US" dirty="0"/>
           </a:p>
@@ -601,7 +601,7 @@
           <a:p>
             <a:r>
               <a:rPr lang="en-US" dirty="0"/>
-              <a:t>Data flow (≈70s). Let me walk through what actually happens between the user typing a URL and seeing a project card. Step one — the URL hash changes. App.tsx uses useSyncExternalStore to listen for hashchange events, parses the hash, and decides which page component to mount. Step two — UserPage mounts and immediately calls loadUserPageData from lib/pageData.ts. Step three — pageData asks Supabase for three things in parallel: the profile row for this username, the folders that user has created, and their portfolio_items. Step four — in the same load, pageData calls github.ts, which fetches the GitHub user, their repos, and, for each repo, tries to grab portfolio.yaml. All of those go out as parallel promises. Step five — results come back and get merged into Project objects. UserPage uses useMemo to bucket them into folders and 'unfiled.' Step six — the component renders ProjectCards inside each section. If you're the owner, the edit view swaps in drag-and-reorder handlers that write back through portfolio.ts. The important thing is that all six steps live in plain React — no framework of mine, no service workers, no server-side rendering.</a:t>
+              <a:t/>
             </a:r>
             <a:endParaRPr lang="en-US" dirty="0"/>
           </a:p>
@@ -689,7 +689,7 @@
           <a:p>
             <a:r>
               <a:rPr lang="en-US" dirty="0"/>
-              <a:t>Styling (≈45s). I deliberately skipped a CSS framework. The whole visual system lives in one styles.css file. At the top is a :root block with CSS custom properties for every colour and a few spacing rules — that's the design system. Class names follow BEM, so components like .project-card have clear modifiers and sub-elements. Why bother? Two reasons. One — zero runtime cost. The browser just reads CSS, there's no build-time JIT like Tailwind. Two — the tokens are the source of truth. When I wanted to shift the whole site one shade cooler, I changed five variables, not fifty components. It's boring, but that's the point.</a:t>
+              <a:t/>
             </a:r>
             <a:endParaRPr lang="en-US" dirty="0"/>
           </a:p>
@@ -777,7 +777,7 @@
           <a:p>
             <a:r>
               <a:rPr lang="en-US" dirty="0"/>
-              <a:t>Close (≈30s). That was Architect.Dev — React and TypeScript on the front, Supabase for auth and data, GitHub's REST API plus a tiny YAML convention for project content, and plain CSS with custom properties for the look. Happy to dig into any layer you're curious about. Thanks.</a:t>
+              <a:t/>
             </a:r>
             <a:endParaRPr lang="en-US" dirty="0"/>
           </a:p>
@@ -865,7 +865,7 @@
           <a:p>
             <a:r>
               <a:rPr lang="en-US" dirty="0"/>
-              <a:t>What it is (≈45s). The product side in one breath: sign in with GitHub, pick the repos you're proud of, publish a curated site. Three things that make it more than a static template. One — it's live. Stars, language tags, timestamps come from the GitHub API at render time. Two — it's configurable per repo. Any project can ship a tiny YAML file to override its title, description, and tags. Three — there's an integrated CV, editable from the same login. That's the whole product surface; the rest of the talk is how it actually works.</a:t>
+              <a:t/>
             </a:r>
             <a:endParaRPr lang="en-US" dirty="0"/>
           </a:p>
@@ -953,7 +953,7 @@
           <a:p>
             <a:r>
               <a:rPr lang="en-US" dirty="0"/>
-              <a:t>What the user sees (≈40s). Quick visual before we go under the hood. This whole page is generated at runtime. Every project card is built from a GitHub repo plus an optional YAML override. No one writes HTML for these cards — the next slides show where the data actually comes from.</a:t>
+              <a:t/>
             </a:r>
             <a:endParaRPr lang="en-US" dirty="0"/>
           </a:p>
@@ -1041,7 +1041,7 @@
           <a:p>
             <a:r>
               <a:rPr lang="en-US" dirty="0"/>
-              <a:t>Architecture (≈65s). At the highest level the system is just three things that talk to each other. The browser runs a React app — that's the only piece I actually wrote. Supabase gives me two things in one service: authentication, including the GitHub OAuth flow, and a Postgres database with four tables — profiles, folders, portfolio_items, and cvs. GitHub is the third piece. I call the REST API for user and repo data, and I fetch portfolio.yaml files directly from raw.githubusercontent.com. I don't run a server of my own. The browser talks directly to Supabase with an anonymous key, and directly to GitHub. The next five slides each zoom into one of these pieces.</a:t>
+              <a:t/>
             </a:r>
             <a:endParaRPr lang="en-US" dirty="0"/>
           </a:p>
@@ -1129,7 +1129,7 @@
           <a:p>
             <a:r>
               <a:rPr lang="en-US" dirty="0"/>
-              <a:t>Frontend (≈70s). The UI is a standard React 19 + TypeScript app, built with Vite. A few choices worth calling out. First, there are only about a dozen components — four page-level ones for routes and a handful of smaller pieces like ProjectCard. I kept the tree shallow. Second, I didn't pull in react-router. Routing is hash-based and driven by useSyncExternalStore listening to hashchange events. Third, state is plain React hooks — useState, useEffect, useMemo, useTransition for optimistic updates. No Redux, no Context, and no custom hooks library. Fourth, types live right next to the fetch functions that produce them. Profile is defined in lib/portfolio.ts, Project in lib/github.ts. That way, whenever I change an API shape, TypeScript immediately tells me which components are now wrong. Vite is mostly invisible but matters — instant hot reload while developing and small production bundles.</a:t>
+              <a:t/>
             </a:r>
             <a:endParaRPr lang="en-US" dirty="0"/>
           </a:p>
@@ -1217,7 +1217,7 @@
           <a:p>
             <a:r>
               <a:rPr lang="en-US" dirty="0"/>
-              <a:t>React, up close (≈75s). Zoom into how the React side actually works. No Redux, no Context, no custom hook library — each part of the UI uses the smallest primitive that does the job. useState holds the pieces of truth a page needs: who's signed in, what data has loaded, whether we're still loading, and any edit-form buffers. useEffect does the async work on mount or when the URL changes. A cancelled flag in the cleanup function means if you navigate away mid-load, the stale fetch can't overwrite fresh state. useMemo turns the flat list of projects into folder buckets plus an 'unfiled' section and a 'hidden' section. It only recomputes when the inputs actually change, which matters because that bucketing runs on every render. useTransition is what keeps edit mode snappy. When you drag a project to a new folder, the UI updates immediately and the Supabase write is marked as a low-priority background update. useSyncExternalStore is a newer React 18/19 primitive. I use it to subscribe to the browser's hashchange event — the URL fragment becomes just another React value, and I didn't have to pull in a router library. And finally, composition. The UserPage component owns data loading. It then renders either a ReaderView or an OwnerView depending on whether you're logged in as this user. Both share a ProjectCard leaf. Classic React: one component per concern, stitched together by props.</a:t>
+              <a:t/>
             </a:r>
             <a:endParaRPr lang="en-US" dirty="0"/>
           </a:p>
@@ -1305,7 +1305,7 @@
           <a:p>
             <a:r>
               <a:rPr lang="en-US" dirty="0"/>
-              <a:t>Backend (≈65s). I didn't write a backend — I use Supabase. It's a managed Postgres database with authentication bolted on, exposed via an auto-generated API and a typed JavaScript SDK. There are four tables, and they should be easy to reason about. 'profiles' is one row per user — bio, display name. 'folders' group projects on a portfolio — name and position. 'portfolio_items' is the selection table: which GitHub repos this user has chosen to show, their order, and whether they're hidden. 'cvs' is a per-user CV stored as a JSON blob, one row per user. Two things Supabase handles that I'd otherwise have to build. Authentication — GitHub OAuth works out of the box, and I just subscribe to onAuthStateChange. And row-level security: the rules that say 'only this user can edit their own portfolio items' live in the database, not scattered across my code. Net effect: there's no server of mine to deploy or monitor.</a:t>
+              <a:t/>
             </a:r>
             <a:endParaRPr lang="en-US" dirty="0"/>
           </a:p>
@@ -1393,7 +1393,7 @@
           <a:p>
             <a:r>
               <a:rPr lang="en-US" dirty="0"/>
-              <a:t>Live data (≈70s). Two sources come together to build a project card. From GitHub's REST API I fetch the user and their repos — up to a hundred — sorted by recency. Forks get filtered out, and the rest get re-sorted by stars then last-updated. For each visible repo I then make a second request to raw.githubusercontent.com, trying to fetch a file called portfolio.yaml from the default branch. If it exists, I parse it with the yaml npm package. If it doesn't, that's fine — the repo just uses GitHub's own metadata. Merging is the simplest possible rule: YAML fields win, GitHub fills the gaps. So title, description, and tags come from the YAML if present; stars, language, and last-updated always come from GitHub. The result is a normalized Project object, which is what the UI actually renders. That's the entire data-layer trick.</a:t>
+              <a:t/>
             </a:r>
             <a:endParaRPr lang="en-US" dirty="0"/>
           </a:p>
@@ -1481,7 +1481,7 @@
           <a:p>
             <a:r>
               <a:rPr lang="en-US" dirty="0"/>
-              <a:t>Code organisation (≈55s). Here's the whole src/ folder. The top-level files are the UI — one file per page, plus ProjectCard for the repeated project row. Everything in lib/ is the data layer: supabase.ts owns the client and auth; portfolio.ts owns database operations for profiles, folders and items; github.ts owns the API calls and the YAML merge; cv.ts owns the CV table; pageData.ts is a small request cache so we don't hit GitHub twice for the same page. Two conventions I stuck to. One — components never import the Supabase SDK or call fetch directly. They go through lib/ functions. That way if I swap Supabase for something else, the UI doesn't care. Two — each file in lib/ has one responsibility. github.ts doesn't know about profiles. portfolio.ts doesn't know about GitHub. They meet in pageData.ts, which is the only place that orchestrates both.</a:t>
+              <a:t/>
             </a:r>
             <a:endParaRPr lang="en-US" dirty="0"/>
           </a:p>
@@ -2701,7 +2701,7 @@
                 <a:ea typeface="Inter" pitchFamily="34" charset="-122"/>
                 <a:cs typeface="Inter" pitchFamily="34" charset="-120"/>
               </a:rPr>
-              <a:t>user profile, repos, and each portfolio.yaml in parallel.</a:t>
+              <a:t>user profile + repos list — up to 100, sorted by stars.</a:t>
             </a:r>
             <a:endParaRPr lang="en-US" sz="1050" dirty="0"/>
           </a:p>
@@ -2818,7 +2818,7 @@
                 <a:ea typeface="Inter" pitchFamily="34" charset="-122"/>
                 <a:cs typeface="Inter" pitchFamily="34" charset="-120"/>
               </a:rPr>
-              <a:t>Projects are bucketed into folders with useMemo.</a:t>
+              <a:t>Overrides apply, then projects bucket into folders with useMemo.</a:t>
             </a:r>
             <a:endParaRPr lang="en-US" sz="1050" dirty="0"/>
           </a:p>
@@ -3314,7 +3314,7 @@
                 <a:ea typeface="Courier New" pitchFamily="34" charset="-122"/>
                 <a:cs typeface="Courier New" pitchFamily="34" charset="-120"/>
               </a:rPr>
-              <a:t>  --bg:    #0b1326;</a:t>
+              <a:t>  --surface:    #0b1326;</a:t>
             </a:r>
             <a:endParaRPr lang="en-US" sz="1300" dirty="0"/>
           </a:p>
@@ -3334,7 +3334,7 @@
                 <a:ea typeface="Courier New" pitchFamily="34" charset="-122"/>
                 <a:cs typeface="Courier New" pitchFamily="34" charset="-120"/>
               </a:rPr>
-              <a:t>  --text:  #e7ecf5;</a:t>
+              <a:t>  --primary:    #c0c1ff;</a:t>
             </a:r>
             <a:endParaRPr lang="en-US" sz="1300" dirty="0"/>
           </a:p>
@@ -3354,7 +3354,7 @@
                 <a:ea typeface="Courier New" pitchFamily="34" charset="-122"/>
                 <a:cs typeface="Courier New" pitchFamily="34" charset="-120"/>
               </a:rPr>
-              <a:t>  --accent:#c0c1ff;</a:t>
+              <a:t>  --on-surface: #dae2fd;</a:t>
             </a:r>
             <a:endParaRPr lang="en-US" sz="1300" dirty="0"/>
           </a:p>
@@ -3374,7 +3374,7 @@
                 <a:ea typeface="Courier New" pitchFamily="34" charset="-122"/>
                 <a:cs typeface="Courier New" pitchFamily="34" charset="-120"/>
               </a:rPr>
-              <a:t>  --panel: #141f3d;</a:t>
+              <a:t>  --accent:     #9dc4ff;</a:t>
             </a:r>
             <a:endParaRPr lang="en-US" sz="1300" dirty="0"/>
           </a:p>
@@ -3394,7 +3394,7 @@
                 <a:ea typeface="Courier New" pitchFamily="34" charset="-122"/>
                 <a:cs typeface="Courier New" pitchFamily="34" charset="-120"/>
               </a:rPr>
-              <a:t>  --line:  #2a3660;</a:t>
+              <a:t>  --tertiary:   #ffb784;</a:t>
             </a:r>
             <a:endParaRPr lang="en-US" sz="1300" dirty="0"/>
           </a:p>
@@ -3723,7 +3723,7 @@
                 <a:ea typeface="Space Grotesk" pitchFamily="34" charset="-122"/>
                 <a:cs typeface="Space Grotesk" pitchFamily="34" charset="-120"/>
               </a:rPr>
-              <a:t>BEM class names.</a:t>
+              <a:t>BEM-ish class names.</a:t>
             </a:r>
             <a:endParaRPr lang="en-US" sz="1200" dirty="0"/>
           </a:p>
@@ -3762,7 +3762,7 @@
                 <a:ea typeface="Inter" pitchFamily="34" charset="-122"/>
                 <a:cs typeface="Inter" pitchFamily="34" charset="-120"/>
               </a:rPr>
-              <a:t>.project-card, .project-card__top, .project-card--featured. Easy to grep.</a:t>
+              <a:t>.proj, .proj__title, .proj__meta — block, element, modifier. Easy to grep.</a:t>
             </a:r>
             <a:endParaRPr lang="en-US" sz="1000" dirty="0"/>
           </a:p>
@@ -4410,7 +4410,7 @@
                 <a:ea typeface="Space Grotesk" pitchFamily="34" charset="-122"/>
                 <a:cs typeface="Space Grotesk" pitchFamily="34" charset="-120"/>
               </a:rPr>
-              <a:t>GitHub API</a:t>
+              <a:t>Postgres</a:t>
             </a:r>
             <a:endParaRPr lang="en-US" sz="1050" dirty="0"/>
           </a:p>
@@ -4474,7 +4474,7 @@
                 <a:ea typeface="Space Grotesk" pitchFamily="34" charset="-122"/>
                 <a:cs typeface="Space Grotesk" pitchFamily="34" charset="-120"/>
               </a:rPr>
-              <a:t>YAML</a:t>
+              <a:t>GitHub API</a:t>
             </a:r>
             <a:endParaRPr lang="en-US" sz="1050" dirty="0"/>
           </a:p>
@@ -4724,7 +4724,7 @@
                 <a:ea typeface="Inter" pitchFamily="34" charset="-122"/>
                 <a:cs typeface="Inter" pitchFamily="34" charset="-120"/>
               </a:rPr>
-              <a:t>Sign in with GitHub, pick the repos you're proud of, and publish a curated portfolio site. The site pulls live data from GitHub and lets each repo define its own presentation through a small YAML file.</a:t>
+              <a:t>Sign in with GitHub, pick the repos you're proud of, and publish a curated portfolio site. The site pulls live data from GitHub and lets owners override each project's title and description right from the dashboard.</a:t>
             </a:r>
             <a:endParaRPr lang="en-US" sz="1500" dirty="0"/>
           </a:p>
@@ -4941,7 +4941,7 @@
                 <a:ea typeface="Space Grotesk" pitchFamily="34" charset="-122"/>
                 <a:cs typeface="Space Grotesk" pitchFamily="34" charset="-120"/>
               </a:rPr>
-              <a:t>Per-repo config</a:t>
+              <a:t>Edit in place</a:t>
             </a:r>
             <a:endParaRPr lang="en-US" sz="1600" dirty="0"/>
           </a:p>
@@ -4980,7 +4980,7 @@
                 <a:ea typeface="Inter" pitchFamily="34" charset="-122"/>
                 <a:cs typeface="Inter" pitchFamily="34" charset="-120"/>
               </a:rPr>
-              <a:t>Drop a portfolio.yaml to override title, description, tags.</a:t>
+              <a:t>Override each project's title and description from the owner dashboard — no re-deploy.</a:t>
             </a:r>
             <a:endParaRPr lang="en-US" sz="1150" dirty="0"/>
           </a:p>
@@ -5375,7 +5375,7 @@
                 <a:ea typeface="Inter" pitchFamily="34" charset="-122"/>
                 <a:cs typeface="Inter" pitchFamily="34" charset="-120"/>
               </a:rPr>
-              <a:t>This is the rendered portfolio. Every card you see is built from a GitHub repository, optionally enriched with a per-repo YAML file. No CMS, no handwritten HTML.</a:t>
+              <a:t>Every card on the portfolio is built from a GitHub repository, with the owner's own title and description applied on top. No CMS, no handwritten HTML.</a:t>
             </a:r>
             <a:endParaRPr lang="en-US" sz="1300" dirty="0"/>
           </a:p>
@@ -5389,14 +5389,14 @@
         </p:nvSpPr>
         <p:spPr>
           <a:xfrm>
-            <a:off x="6334220" y="566928"/>
-            <a:ext cx="1596200" cy="4078224"/>
+            <a:off x="5394960" y="640080"/>
+            <a:ext cx="3383280" cy="3931920"/>
           </a:xfrm>
           <a:prstGeom prst="rect">
             <a:avLst/>
           </a:prstGeom>
           <a:solidFill>
-            <a:srgbClr val="1B2749"/>
+            <a:srgbClr val="111B36"/>
           </a:solidFill>
           <a:ln w="9525">
             <a:solidFill>
@@ -5406,40 +5406,311 @@
           </a:ln>
         </p:spPr>
       </p:sp>
-      <p:pic>
-        <p:nvPicPr>
-          <p:cNvPr id="6" name="Image 0" descr="/sessions/sleepy-brave-cannon/mnt/portfolio/design-example/home_landing_page/screen.png">    </p:cNvPr>
-          <p:cNvPicPr>
-            <a:picLocks noChangeAspect="1"/>
-          </p:cNvPicPr>
-          <p:nvPr/>
-        </p:nvPicPr>
-        <p:blipFill>
-          <a:blip r:embed="rId1"/>
-          <a:stretch>
-            <a:fillRect/>
-          </a:stretch>
-        </p:blipFill>
-        <p:spPr>
-          <a:xfrm>
-            <a:off x="6407372" y="640080"/>
-            <a:ext cx="1449896" cy="3931920"/>
-          </a:xfrm>
-          <a:prstGeom prst="rect">
-            <a:avLst/>
-          </a:prstGeom>
-        </p:spPr>
-      </p:pic>
-      <p:sp>
-        <p:nvSpPr>
-          <p:cNvPr id="7" name="Shape 4"/>
-          <p:cNvSpPr/>
-          <p:nvPr/>
-        </p:nvSpPr>
-        <p:spPr>
-          <a:xfrm>
-            <a:off x="457200" y="4828032"/>
-            <a:ext cx="8229600" cy="0"/>
+      <p:sp>
+        <p:nvSpPr>
+          <p:cNvPr id="6" name="Shape 4"/>
+          <p:cNvSpPr/>
+          <p:nvPr/>
+        </p:nvSpPr>
+        <p:spPr>
+          <a:xfrm>
+            <a:off x="5394960" y="640080"/>
+            <a:ext cx="3383280" cy="292608"/>
+          </a:xfrm>
+          <a:prstGeom prst="rect">
+            <a:avLst/>
+          </a:prstGeom>
+          <a:solidFill>
+            <a:srgbClr val="1B2749"/>
+          </a:solidFill>
+          <a:ln w="12700">
+            <a:solidFill>
+              <a:srgbClr val="2A3660"/>
+            </a:solidFill>
+            <a:prstDash val="solid"/>
+          </a:ln>
+        </p:spPr>
+      </p:sp>
+      <p:sp>
+        <p:nvSpPr>
+          <p:cNvPr id="7" name="Shape 5"/>
+          <p:cNvSpPr/>
+          <p:nvPr/>
+        </p:nvSpPr>
+        <p:spPr>
+          <a:xfrm>
+            <a:off x="5504688" y="731520"/>
+            <a:ext cx="100584" cy="100584"/>
+          </a:xfrm>
+          <a:prstGeom prst="ellipse">
+            <a:avLst/>
+          </a:prstGeom>
+          <a:solidFill>
+            <a:srgbClr val="F96167"/>
+          </a:solidFill>
+          <a:ln w="12700">
+            <a:solidFill>
+              <a:srgbClr val="2A3660"/>
+            </a:solidFill>
+            <a:prstDash val="solid"/>
+          </a:ln>
+        </p:spPr>
+      </p:sp>
+      <p:sp>
+        <p:nvSpPr>
+          <p:cNvPr id="8" name="Shape 6"/>
+          <p:cNvSpPr/>
+          <p:nvPr/>
+        </p:nvSpPr>
+        <p:spPr>
+          <a:xfrm>
+            <a:off x="5650992" y="731520"/>
+            <a:ext cx="100584" cy="100584"/>
+          </a:xfrm>
+          <a:prstGeom prst="ellipse">
+            <a:avLst/>
+          </a:prstGeom>
+          <a:solidFill>
+            <a:srgbClr val="F4B183"/>
+          </a:solidFill>
+          <a:ln w="12700">
+            <a:solidFill>
+              <a:srgbClr val="2A3660"/>
+            </a:solidFill>
+            <a:prstDash val="solid"/>
+          </a:ln>
+        </p:spPr>
+      </p:sp>
+      <p:sp>
+        <p:nvSpPr>
+          <p:cNvPr id="9" name="Shape 7"/>
+          <p:cNvSpPr/>
+          <p:nvPr/>
+        </p:nvSpPr>
+        <p:spPr>
+          <a:xfrm>
+            <a:off x="5797296" y="731520"/>
+            <a:ext cx="100584" cy="100584"/>
+          </a:xfrm>
+          <a:prstGeom prst="ellipse">
+            <a:avLst/>
+          </a:prstGeom>
+          <a:solidFill>
+            <a:srgbClr val="7EE3C1"/>
+          </a:solidFill>
+          <a:ln w="12700">
+            <a:solidFill>
+              <a:srgbClr val="2A3660"/>
+            </a:solidFill>
+            <a:prstDash val="solid"/>
+          </a:ln>
+        </p:spPr>
+      </p:sp>
+      <p:sp>
+        <p:nvSpPr>
+          <p:cNvPr id="10" name="Text 8"/>
+          <p:cNvSpPr/>
+          <p:nvPr/>
+        </p:nvSpPr>
+        <p:spPr>
+          <a:xfrm>
+            <a:off x="6035040" y="694944"/>
+            <a:ext cx="2651760" cy="201168"/>
+          </a:xfrm>
+          <a:prstGeom prst="rect">
+            <a:avLst/>
+          </a:prstGeom>
+          <a:noFill/>
+          <a:ln/>
+        </p:spPr>
+        <p:txBody>
+          <a:bodyPr wrap="square" lIns="0" tIns="0" rIns="0" bIns="0" rtlCol="0" anchor="ctr"/>
+          <a:lstStyle/>
+          <a:p>
+            <a:pPr indent="0" marL="0">
+              <a:buNone/>
+            </a:pPr>
+            <a:r>
+              <a:rPr lang="en-US" sz="800" dirty="0">
+                <a:solidFill>
+                  <a:srgbClr val="6E7699"/>
+                </a:solidFill>
+                <a:latin typeface="Courier New" pitchFamily="34" charset="0"/>
+                <a:ea typeface="Courier New" pitchFamily="34" charset="-122"/>
+                <a:cs typeface="Courier New" pitchFamily="34" charset="-120"/>
+              </a:rPr>
+              <a:t>architect.dev/u/gusbo9233</a:t>
+            </a:r>
+            <a:endParaRPr lang="en-US" sz="800" dirty="0"/>
+          </a:p>
+        </p:txBody>
+      </p:sp>
+      <p:sp>
+        <p:nvSpPr>
+          <p:cNvPr id="11" name="Text 9"/>
+          <p:cNvSpPr/>
+          <p:nvPr/>
+        </p:nvSpPr>
+        <p:spPr>
+          <a:xfrm>
+            <a:off x="5577840" y="1097280"/>
+            <a:ext cx="3017520" cy="274320"/>
+          </a:xfrm>
+          <a:prstGeom prst="rect">
+            <a:avLst/>
+          </a:prstGeom>
+          <a:noFill/>
+          <a:ln/>
+        </p:spPr>
+        <p:txBody>
+          <a:bodyPr wrap="square" lIns="0" tIns="0" rIns="0" bIns="0" rtlCol="0" anchor="ctr"/>
+          <a:lstStyle/>
+          <a:p>
+            <a:pPr indent="0" marL="0">
+              <a:buNone/>
+            </a:pPr>
+            <a:r>
+              <a:rPr lang="en-US" sz="1600" b="1" dirty="0">
+                <a:solidFill>
+                  <a:srgbClr val="FFFFFF"/>
+                </a:solidFill>
+                <a:latin typeface="Space Grotesk" pitchFamily="34" charset="0"/>
+                <a:ea typeface="Space Grotesk" pitchFamily="34" charset="-122"/>
+                <a:cs typeface="Space Grotesk" pitchFamily="34" charset="-120"/>
+              </a:rPr>
+              <a:t>Manfred</a:t>
+            </a:r>
+            <a:endParaRPr lang="en-US" sz="1600" dirty="0"/>
+          </a:p>
+        </p:txBody>
+      </p:sp>
+      <p:sp>
+        <p:nvSpPr>
+          <p:cNvPr id="12" name="Text 10"/>
+          <p:cNvSpPr/>
+          <p:nvPr/>
+        </p:nvSpPr>
+        <p:spPr>
+          <a:xfrm>
+            <a:off x="5577840" y="1389888"/>
+            <a:ext cx="3017520" cy="201168"/>
+          </a:xfrm>
+          <a:prstGeom prst="rect">
+            <a:avLst/>
+          </a:prstGeom>
+          <a:noFill/>
+          <a:ln/>
+        </p:spPr>
+        <p:txBody>
+          <a:bodyPr wrap="square" lIns="0" tIns="0" rIns="0" bIns="0" rtlCol="0" anchor="ctr"/>
+          <a:lstStyle/>
+          <a:p>
+            <a:pPr indent="0" marL="0">
+              <a:buNone/>
+            </a:pPr>
+            <a:r>
+              <a:rPr lang="en-US" sz="900" i="1" dirty="0">
+                <a:solidFill>
+                  <a:srgbClr val="A7ADC6"/>
+                </a:solidFill>
+                <a:latin typeface="Inter" pitchFamily="34" charset="0"/>
+                <a:ea typeface="Inter" pitchFamily="34" charset="-122"/>
+                <a:cs typeface="Inter" pitchFamily="34" charset="-120"/>
+              </a:rPr>
+              <a:t>building small things in typescript</a:t>
+            </a:r>
+            <a:endParaRPr lang="en-US" sz="900" dirty="0"/>
+          </a:p>
+        </p:txBody>
+      </p:sp>
+      <p:sp>
+        <p:nvSpPr>
+          <p:cNvPr id="13" name="Text 11"/>
+          <p:cNvSpPr/>
+          <p:nvPr/>
+        </p:nvSpPr>
+        <p:spPr>
+          <a:xfrm>
+            <a:off x="5577840" y="1600200"/>
+            <a:ext cx="1371600" cy="182880"/>
+          </a:xfrm>
+          <a:prstGeom prst="rect">
+            <a:avLst/>
+          </a:prstGeom>
+          <a:noFill/>
+          <a:ln/>
+        </p:spPr>
+        <p:txBody>
+          <a:bodyPr wrap="square" lIns="0" tIns="0" rIns="0" bIns="0" rtlCol="0" anchor="ctr"/>
+          <a:lstStyle/>
+          <a:p>
+            <a:pPr indent="0" marL="0">
+              <a:buNone/>
+            </a:pPr>
+            <a:r>
+              <a:rPr lang="en-US" sz="800" b="1" spc="300" kern="0" dirty="0">
+                <a:solidFill>
+                  <a:srgbClr val="C0C1FF"/>
+                </a:solidFill>
+                <a:latin typeface="Space Grotesk" pitchFamily="34" charset="0"/>
+                <a:ea typeface="Space Grotesk" pitchFamily="34" charset="-122"/>
+                <a:cs typeface="Space Grotesk" pitchFamily="34" charset="-120"/>
+              </a:rPr>
+              <a:t>PROJECTS</a:t>
+            </a:r>
+            <a:endParaRPr lang="en-US" sz="800" dirty="0"/>
+          </a:p>
+        </p:txBody>
+      </p:sp>
+      <p:sp>
+        <p:nvSpPr>
+          <p:cNvPr id="14" name="Text 12"/>
+          <p:cNvSpPr/>
+          <p:nvPr/>
+        </p:nvSpPr>
+        <p:spPr>
+          <a:xfrm>
+            <a:off x="6949440" y="1600200"/>
+            <a:ext cx="548640" cy="182880"/>
+          </a:xfrm>
+          <a:prstGeom prst="rect">
+            <a:avLst/>
+          </a:prstGeom>
+          <a:noFill/>
+          <a:ln/>
+        </p:spPr>
+        <p:txBody>
+          <a:bodyPr wrap="square" lIns="0" tIns="0" rIns="0" bIns="0" rtlCol="0" anchor="ctr"/>
+          <a:lstStyle/>
+          <a:p>
+            <a:pPr indent="0" marL="0">
+              <a:buNone/>
+            </a:pPr>
+            <a:r>
+              <a:rPr lang="en-US" sz="800" b="1" spc="300" kern="0" dirty="0">
+                <a:solidFill>
+                  <a:srgbClr val="6E7699"/>
+                </a:solidFill>
+                <a:latin typeface="Space Grotesk" pitchFamily="34" charset="0"/>
+                <a:ea typeface="Space Grotesk" pitchFamily="34" charset="-122"/>
+                <a:cs typeface="Space Grotesk" pitchFamily="34" charset="-120"/>
+              </a:rPr>
+              <a:t>CV</a:t>
+            </a:r>
+            <a:endParaRPr lang="en-US" sz="800" dirty="0"/>
+          </a:p>
+        </p:txBody>
+      </p:sp>
+      <p:sp>
+        <p:nvSpPr>
+          <p:cNvPr id="15" name="Shape 13"/>
+          <p:cNvSpPr/>
+          <p:nvPr/>
+        </p:nvSpPr>
+        <p:spPr>
+          <a:xfrm>
+            <a:off x="5577840" y="1810512"/>
+            <a:ext cx="3017520" cy="0"/>
           </a:xfrm>
           <a:prstGeom prst="line">
             <a:avLst/>
@@ -5455,37 +5726,623 @@
       </p:sp>
       <p:sp>
         <p:nvSpPr>
-          <p:cNvPr id="8" name="Text 5"/>
-          <p:cNvSpPr/>
-          <p:nvPr/>
-        </p:nvSpPr>
-        <p:spPr>
-          <a:xfrm>
-            <a:off x="457200" y="4864608"/>
-            <a:ext cx="2743200" cy="228600"/>
-          </a:xfrm>
-          <a:prstGeom prst="rect">
-            <a:avLst/>
-          </a:prstGeom>
-          <a:noFill/>
-          <a:ln/>
-        </p:spPr>
-        <p:txBody>
-          <a:bodyPr wrap="square" lIns="0" tIns="0" rIns="0" bIns="0" rtlCol="0" anchor="ctr"/>
-          <a:lstStyle/>
-          <a:p>
-            <a:pPr indent="0" marL="0">
-              <a:buNone/>
-            </a:pPr>
-            <a:r>
-              <a:rPr lang="en-US" sz="800" b="1" spc="400" kern="0" dirty="0">
-                <a:solidFill>
-                  <a:srgbClr val="6E7699"/>
+          <p:cNvPr id="16" name="Shape 14"/>
+          <p:cNvSpPr/>
+          <p:nvPr/>
+        </p:nvSpPr>
+        <p:spPr>
+          <a:xfrm>
+            <a:off x="5577840" y="1810512"/>
+            <a:ext cx="914400" cy="0"/>
+          </a:xfrm>
+          <a:prstGeom prst="line">
+            <a:avLst/>
+          </a:prstGeom>
+          <a:noFill/>
+          <a:ln w="19050">
+            <a:solidFill>
+              <a:srgbClr val="C0C1FF"/>
+            </a:solidFill>
+            <a:prstDash val="solid"/>
+          </a:ln>
+        </p:spPr>
+      </p:sp>
+      <p:sp>
+        <p:nvSpPr>
+          <p:cNvPr id="17" name="Text 15"/>
+          <p:cNvSpPr/>
+          <p:nvPr/>
+        </p:nvSpPr>
+        <p:spPr>
+          <a:xfrm>
+            <a:off x="5577840" y="1965960"/>
+            <a:ext cx="1828800" cy="182880"/>
+          </a:xfrm>
+          <a:prstGeom prst="rect">
+            <a:avLst/>
+          </a:prstGeom>
+          <a:noFill/>
+          <a:ln/>
+        </p:spPr>
+        <p:txBody>
+          <a:bodyPr wrap="square" lIns="0" tIns="0" rIns="0" bIns="0" rtlCol="0" anchor="ctr"/>
+          <a:lstStyle/>
+          <a:p>
+            <a:pPr indent="0" marL="0">
+              <a:buNone/>
+            </a:pPr>
+            <a:r>
+              <a:rPr lang="en-US" sz="800" b="1" spc="300" kern="0" dirty="0">
+                <a:solidFill>
+                  <a:srgbClr val="C0C1FF"/>
                 </a:solidFill>
                 <a:latin typeface="Space Grotesk" pitchFamily="34" charset="0"/>
                 <a:ea typeface="Space Grotesk" pitchFamily="34" charset="-122"/>
                 <a:cs typeface="Space Grotesk" pitchFamily="34" charset="-120"/>
               </a:rPr>
+              <a:t>FEATURED</a:t>
+            </a:r>
+            <a:endParaRPr lang="en-US" sz="800" dirty="0"/>
+          </a:p>
+        </p:txBody>
+      </p:sp>
+      <p:sp>
+        <p:nvSpPr>
+          <p:cNvPr id="18" name="Shape 16"/>
+          <p:cNvSpPr/>
+          <p:nvPr/>
+        </p:nvSpPr>
+        <p:spPr>
+          <a:xfrm>
+            <a:off x="5577840" y="2286000"/>
+            <a:ext cx="3017520" cy="594360"/>
+          </a:xfrm>
+          <a:prstGeom prst="rect">
+            <a:avLst/>
+          </a:prstGeom>
+          <a:solidFill>
+            <a:srgbClr val="141F3D"/>
+          </a:solidFill>
+          <a:ln w="6350">
+            <a:solidFill>
+              <a:srgbClr val="2A3660"/>
+            </a:solidFill>
+            <a:prstDash val="solid"/>
+          </a:ln>
+        </p:spPr>
+      </p:sp>
+      <p:sp>
+        <p:nvSpPr>
+          <p:cNvPr id="19" name="Shape 17"/>
+          <p:cNvSpPr/>
+          <p:nvPr/>
+        </p:nvSpPr>
+        <p:spPr>
+          <a:xfrm>
+            <a:off x="5577840" y="2286000"/>
+            <a:ext cx="36576" cy="594360"/>
+          </a:xfrm>
+          <a:prstGeom prst="rect">
+            <a:avLst/>
+          </a:prstGeom>
+          <a:solidFill>
+            <a:srgbClr val="C0C1FF"/>
+          </a:solidFill>
+          <a:ln w="12700">
+            <a:solidFill>
+              <a:srgbClr val="C0C1FF"/>
+            </a:solidFill>
+            <a:prstDash val="solid"/>
+          </a:ln>
+        </p:spPr>
+      </p:sp>
+      <p:sp>
+        <p:nvSpPr>
+          <p:cNvPr id="20" name="Text 18"/>
+          <p:cNvSpPr/>
+          <p:nvPr/>
+        </p:nvSpPr>
+        <p:spPr>
+          <a:xfrm>
+            <a:off x="5715000" y="2359152"/>
+            <a:ext cx="2286000" cy="201168"/>
+          </a:xfrm>
+          <a:prstGeom prst="rect">
+            <a:avLst/>
+          </a:prstGeom>
+          <a:noFill/>
+          <a:ln/>
+        </p:spPr>
+        <p:txBody>
+          <a:bodyPr wrap="square" lIns="0" tIns="0" rIns="0" bIns="0" rtlCol="0" anchor="ctr"/>
+          <a:lstStyle/>
+          <a:p>
+            <a:pPr indent="0" marL="0">
+              <a:buNone/>
+            </a:pPr>
+            <a:r>
+              <a:rPr lang="en-US" sz="1000" b="1" dirty="0">
+                <a:solidFill>
+                  <a:srgbClr val="FFFFFF"/>
+                </a:solidFill>
+                <a:latin typeface="Courier New" pitchFamily="34" charset="0"/>
+                <a:ea typeface="Courier New" pitchFamily="34" charset="-122"/>
+                <a:cs typeface="Courier New" pitchFamily="34" charset="-120"/>
+              </a:rPr>
+              <a:t>portfolio</a:t>
+            </a:r>
+            <a:endParaRPr lang="en-US" sz="1000" dirty="0"/>
+          </a:p>
+        </p:txBody>
+      </p:sp>
+      <p:sp>
+        <p:nvSpPr>
+          <p:cNvPr id="21" name="Text 19"/>
+          <p:cNvSpPr/>
+          <p:nvPr/>
+        </p:nvSpPr>
+        <p:spPr>
+          <a:xfrm>
+            <a:off x="5715000" y="2587752"/>
+            <a:ext cx="2560320" cy="228600"/>
+          </a:xfrm>
+          <a:prstGeom prst="rect">
+            <a:avLst/>
+          </a:prstGeom>
+          <a:noFill/>
+          <a:ln/>
+        </p:spPr>
+        <p:txBody>
+          <a:bodyPr wrap="square" lIns="0" tIns="0" rIns="0" bIns="0" rtlCol="0" anchor="ctr"/>
+          <a:lstStyle/>
+          <a:p>
+            <a:pPr indent="0" marL="0">
+              <a:buNone/>
+            </a:pPr>
+            <a:r>
+              <a:rPr lang="en-US" sz="800" dirty="0">
+                <a:solidFill>
+                  <a:srgbClr val="A7ADC6"/>
+                </a:solidFill>
+                <a:latin typeface="Inter" pitchFamily="34" charset="0"/>
+                <a:ea typeface="Inter" pitchFamily="34" charset="-122"/>
+                <a:cs typeface="Inter" pitchFamily="34" charset="-120"/>
+              </a:rPr>
+              <a:t>react · typescript · supabase</a:t>
+            </a:r>
+            <a:endParaRPr lang="en-US" sz="800" dirty="0"/>
+          </a:p>
+        </p:txBody>
+      </p:sp>
+      <p:sp>
+        <p:nvSpPr>
+          <p:cNvPr id="22" name="Text 20"/>
+          <p:cNvSpPr/>
+          <p:nvPr/>
+        </p:nvSpPr>
+        <p:spPr>
+          <a:xfrm>
+            <a:off x="8001000" y="2359152"/>
+            <a:ext cx="594360" cy="201168"/>
+          </a:xfrm>
+          <a:prstGeom prst="rect">
+            <a:avLst/>
+          </a:prstGeom>
+          <a:noFill/>
+          <a:ln/>
+        </p:spPr>
+        <p:txBody>
+          <a:bodyPr wrap="square" lIns="0" tIns="0" rIns="0" bIns="0" rtlCol="0" anchor="ctr"/>
+          <a:lstStyle/>
+          <a:p>
+            <a:pPr algn="r" indent="0" marL="0">
+              <a:buNone/>
+            </a:pPr>
+            <a:r>
+              <a:rPr lang="en-US" sz="900" b="1" dirty="0">
+                <a:solidFill>
+                  <a:srgbClr val="C0C1FF"/>
+                </a:solidFill>
+                <a:latin typeface="Space Grotesk" pitchFamily="34" charset="0"/>
+                <a:ea typeface="Space Grotesk" pitchFamily="34" charset="-122"/>
+                <a:cs typeface="Space Grotesk" pitchFamily="34" charset="-120"/>
+              </a:rPr>
+              <a:t>★ 24</a:t>
+            </a:r>
+            <a:endParaRPr lang="en-US" sz="900" dirty="0"/>
+          </a:p>
+        </p:txBody>
+      </p:sp>
+      <p:sp>
+        <p:nvSpPr>
+          <p:cNvPr id="23" name="Shape 21"/>
+          <p:cNvSpPr/>
+          <p:nvPr/>
+        </p:nvSpPr>
+        <p:spPr>
+          <a:xfrm>
+            <a:off x="5577840" y="2999232"/>
+            <a:ext cx="3017520" cy="594360"/>
+          </a:xfrm>
+          <a:prstGeom prst="rect">
+            <a:avLst/>
+          </a:prstGeom>
+          <a:solidFill>
+            <a:srgbClr val="141F3D"/>
+          </a:solidFill>
+          <a:ln w="6350">
+            <a:solidFill>
+              <a:srgbClr val="2A3660"/>
+            </a:solidFill>
+            <a:prstDash val="solid"/>
+          </a:ln>
+        </p:spPr>
+      </p:sp>
+      <p:sp>
+        <p:nvSpPr>
+          <p:cNvPr id="24" name="Shape 22"/>
+          <p:cNvSpPr/>
+          <p:nvPr/>
+        </p:nvSpPr>
+        <p:spPr>
+          <a:xfrm>
+            <a:off x="5577840" y="2999232"/>
+            <a:ext cx="36576" cy="594360"/>
+          </a:xfrm>
+          <a:prstGeom prst="rect">
+            <a:avLst/>
+          </a:prstGeom>
+          <a:solidFill>
+            <a:srgbClr val="C0C1FF"/>
+          </a:solidFill>
+          <a:ln w="12700">
+            <a:solidFill>
+              <a:srgbClr val="C0C1FF"/>
+            </a:solidFill>
+            <a:prstDash val="solid"/>
+          </a:ln>
+        </p:spPr>
+      </p:sp>
+      <p:sp>
+        <p:nvSpPr>
+          <p:cNvPr id="25" name="Text 23"/>
+          <p:cNvSpPr/>
+          <p:nvPr/>
+        </p:nvSpPr>
+        <p:spPr>
+          <a:xfrm>
+            <a:off x="5715000" y="3072384"/>
+            <a:ext cx="2286000" cy="201168"/>
+          </a:xfrm>
+          <a:prstGeom prst="rect">
+            <a:avLst/>
+          </a:prstGeom>
+          <a:noFill/>
+          <a:ln/>
+        </p:spPr>
+        <p:txBody>
+          <a:bodyPr wrap="square" lIns="0" tIns="0" rIns="0" bIns="0" rtlCol="0" anchor="ctr"/>
+          <a:lstStyle/>
+          <a:p>
+            <a:pPr indent="0" marL="0">
+              <a:buNone/>
+            </a:pPr>
+            <a:r>
+              <a:rPr lang="en-US" sz="1000" b="1" dirty="0">
+                <a:solidFill>
+                  <a:srgbClr val="FFFFFF"/>
+                </a:solidFill>
+                <a:latin typeface="Courier New" pitchFamily="34" charset="0"/>
+                <a:ea typeface="Courier New" pitchFamily="34" charset="-122"/>
+                <a:cs typeface="Courier New" pitchFamily="34" charset="-120"/>
+              </a:rPr>
+              <a:t>architect.dev</a:t>
+            </a:r>
+            <a:endParaRPr lang="en-US" sz="1000" dirty="0"/>
+          </a:p>
+        </p:txBody>
+      </p:sp>
+      <p:sp>
+        <p:nvSpPr>
+          <p:cNvPr id="26" name="Text 24"/>
+          <p:cNvSpPr/>
+          <p:nvPr/>
+        </p:nvSpPr>
+        <p:spPr>
+          <a:xfrm>
+            <a:off x="5715000" y="3300984"/>
+            <a:ext cx="2560320" cy="228600"/>
+          </a:xfrm>
+          <a:prstGeom prst="rect">
+            <a:avLst/>
+          </a:prstGeom>
+          <a:noFill/>
+          <a:ln/>
+        </p:spPr>
+        <p:txBody>
+          <a:bodyPr wrap="square" lIns="0" tIns="0" rIns="0" bIns="0" rtlCol="0" anchor="ctr"/>
+          <a:lstStyle/>
+          <a:p>
+            <a:pPr indent="0" marL="0">
+              <a:buNone/>
+            </a:pPr>
+            <a:r>
+              <a:rPr lang="en-US" sz="800" dirty="0">
+                <a:solidFill>
+                  <a:srgbClr val="A7ADC6"/>
+                </a:solidFill>
+                <a:latin typeface="Inter" pitchFamily="34" charset="0"/>
+                <a:ea typeface="Inter" pitchFamily="34" charset="-122"/>
+                <a:cs typeface="Inter" pitchFamily="34" charset="-120"/>
+              </a:rPr>
+              <a:t>personal site · vite</a:t>
+            </a:r>
+            <a:endParaRPr lang="en-US" sz="800" dirty="0"/>
+          </a:p>
+        </p:txBody>
+      </p:sp>
+      <p:sp>
+        <p:nvSpPr>
+          <p:cNvPr id="27" name="Text 25"/>
+          <p:cNvSpPr/>
+          <p:nvPr/>
+        </p:nvSpPr>
+        <p:spPr>
+          <a:xfrm>
+            <a:off x="8001000" y="3072384"/>
+            <a:ext cx="594360" cy="201168"/>
+          </a:xfrm>
+          <a:prstGeom prst="rect">
+            <a:avLst/>
+          </a:prstGeom>
+          <a:noFill/>
+          <a:ln/>
+        </p:spPr>
+        <p:txBody>
+          <a:bodyPr wrap="square" lIns="0" tIns="0" rIns="0" bIns="0" rtlCol="0" anchor="ctr"/>
+          <a:lstStyle/>
+          <a:p>
+            <a:pPr algn="r" indent="0" marL="0">
+              <a:buNone/>
+            </a:pPr>
+            <a:r>
+              <a:rPr lang="en-US" sz="900" b="1" dirty="0">
+                <a:solidFill>
+                  <a:srgbClr val="C0C1FF"/>
+                </a:solidFill>
+                <a:latin typeface="Space Grotesk" pitchFamily="34" charset="0"/>
+                <a:ea typeface="Space Grotesk" pitchFamily="34" charset="-122"/>
+                <a:cs typeface="Space Grotesk" pitchFamily="34" charset="-120"/>
+              </a:rPr>
+              <a:t>★ 8</a:t>
+            </a:r>
+            <a:endParaRPr lang="en-US" sz="900" dirty="0"/>
+          </a:p>
+        </p:txBody>
+      </p:sp>
+      <p:sp>
+        <p:nvSpPr>
+          <p:cNvPr id="28" name="Shape 26"/>
+          <p:cNvSpPr/>
+          <p:nvPr/>
+        </p:nvSpPr>
+        <p:spPr>
+          <a:xfrm>
+            <a:off x="5577840" y="3712464"/>
+            <a:ext cx="3017520" cy="594360"/>
+          </a:xfrm>
+          <a:prstGeom prst="rect">
+            <a:avLst/>
+          </a:prstGeom>
+          <a:solidFill>
+            <a:srgbClr val="141F3D"/>
+          </a:solidFill>
+          <a:ln w="6350">
+            <a:solidFill>
+              <a:srgbClr val="2A3660"/>
+            </a:solidFill>
+            <a:prstDash val="solid"/>
+          </a:ln>
+        </p:spPr>
+      </p:sp>
+      <p:sp>
+        <p:nvSpPr>
+          <p:cNvPr id="29" name="Shape 27"/>
+          <p:cNvSpPr/>
+          <p:nvPr/>
+        </p:nvSpPr>
+        <p:spPr>
+          <a:xfrm>
+            <a:off x="5577840" y="3712464"/>
+            <a:ext cx="36576" cy="594360"/>
+          </a:xfrm>
+          <a:prstGeom prst="rect">
+            <a:avLst/>
+          </a:prstGeom>
+          <a:solidFill>
+            <a:srgbClr val="C0C1FF"/>
+          </a:solidFill>
+          <a:ln w="12700">
+            <a:solidFill>
+              <a:srgbClr val="C0C1FF"/>
+            </a:solidFill>
+            <a:prstDash val="solid"/>
+          </a:ln>
+        </p:spPr>
+      </p:sp>
+      <p:sp>
+        <p:nvSpPr>
+          <p:cNvPr id="30" name="Text 28"/>
+          <p:cNvSpPr/>
+          <p:nvPr/>
+        </p:nvSpPr>
+        <p:spPr>
+          <a:xfrm>
+            <a:off x="5715000" y="3785616"/>
+            <a:ext cx="2286000" cy="201168"/>
+          </a:xfrm>
+          <a:prstGeom prst="rect">
+            <a:avLst/>
+          </a:prstGeom>
+          <a:noFill/>
+          <a:ln/>
+        </p:spPr>
+        <p:txBody>
+          <a:bodyPr wrap="square" lIns="0" tIns="0" rIns="0" bIns="0" rtlCol="0" anchor="ctr"/>
+          <a:lstStyle/>
+          <a:p>
+            <a:pPr indent="0" marL="0">
+              <a:buNone/>
+            </a:pPr>
+            <a:r>
+              <a:rPr lang="en-US" sz="1000" b="1" dirty="0">
+                <a:solidFill>
+                  <a:srgbClr val="FFFFFF"/>
+                </a:solidFill>
+                <a:latin typeface="Courier New" pitchFamily="34" charset="0"/>
+                <a:ea typeface="Courier New" pitchFamily="34" charset="-122"/>
+                <a:cs typeface="Courier New" pitchFamily="34" charset="-120"/>
+              </a:rPr>
+              <a:t>yaml-merge</a:t>
+            </a:r>
+            <a:endParaRPr lang="en-US" sz="1000" dirty="0"/>
+          </a:p>
+        </p:txBody>
+      </p:sp>
+      <p:sp>
+        <p:nvSpPr>
+          <p:cNvPr id="31" name="Text 29"/>
+          <p:cNvSpPr/>
+          <p:nvPr/>
+        </p:nvSpPr>
+        <p:spPr>
+          <a:xfrm>
+            <a:off x="5715000" y="4014216"/>
+            <a:ext cx="2560320" cy="228600"/>
+          </a:xfrm>
+          <a:prstGeom prst="rect">
+            <a:avLst/>
+          </a:prstGeom>
+          <a:noFill/>
+          <a:ln/>
+        </p:spPr>
+        <p:txBody>
+          <a:bodyPr wrap="square" lIns="0" tIns="0" rIns="0" bIns="0" rtlCol="0" anchor="ctr"/>
+          <a:lstStyle/>
+          <a:p>
+            <a:pPr indent="0" marL="0">
+              <a:buNone/>
+            </a:pPr>
+            <a:r>
+              <a:rPr lang="en-US" sz="800" dirty="0">
+                <a:solidFill>
+                  <a:srgbClr val="A7ADC6"/>
+                </a:solidFill>
+                <a:latin typeface="Inter" pitchFamily="34" charset="0"/>
+                <a:ea typeface="Inter" pitchFamily="34" charset="-122"/>
+                <a:cs typeface="Inter" pitchFamily="34" charset="-120"/>
+              </a:rPr>
+              <a:t>tiny config utility</a:t>
+            </a:r>
+            <a:endParaRPr lang="en-US" sz="800" dirty="0"/>
+          </a:p>
+        </p:txBody>
+      </p:sp>
+      <p:sp>
+        <p:nvSpPr>
+          <p:cNvPr id="32" name="Text 30"/>
+          <p:cNvSpPr/>
+          <p:nvPr/>
+        </p:nvSpPr>
+        <p:spPr>
+          <a:xfrm>
+            <a:off x="8001000" y="3785616"/>
+            <a:ext cx="594360" cy="201168"/>
+          </a:xfrm>
+          <a:prstGeom prst="rect">
+            <a:avLst/>
+          </a:prstGeom>
+          <a:noFill/>
+          <a:ln/>
+        </p:spPr>
+        <p:txBody>
+          <a:bodyPr wrap="square" lIns="0" tIns="0" rIns="0" bIns="0" rtlCol="0" anchor="ctr"/>
+          <a:lstStyle/>
+          <a:p>
+            <a:pPr algn="r" indent="0" marL="0">
+              <a:buNone/>
+            </a:pPr>
+            <a:r>
+              <a:rPr lang="en-US" sz="900" b="1" dirty="0">
+                <a:solidFill>
+                  <a:srgbClr val="C0C1FF"/>
+                </a:solidFill>
+                <a:latin typeface="Space Grotesk" pitchFamily="34" charset="0"/>
+                <a:ea typeface="Space Grotesk" pitchFamily="34" charset="-122"/>
+                <a:cs typeface="Space Grotesk" pitchFamily="34" charset="-120"/>
+              </a:rPr>
+              <a:t>★ 3</a:t>
+            </a:r>
+            <a:endParaRPr lang="en-US" sz="900" dirty="0"/>
+          </a:p>
+        </p:txBody>
+      </p:sp>
+      <p:sp>
+        <p:nvSpPr>
+          <p:cNvPr id="33" name="Shape 31"/>
+          <p:cNvSpPr/>
+          <p:nvPr/>
+        </p:nvSpPr>
+        <p:spPr>
+          <a:xfrm>
+            <a:off x="457200" y="4828032"/>
+            <a:ext cx="8229600" cy="0"/>
+          </a:xfrm>
+          <a:prstGeom prst="line">
+            <a:avLst/>
+          </a:prstGeom>
+          <a:noFill/>
+          <a:ln w="9525">
+            <a:solidFill>
+              <a:srgbClr val="2A3660"/>
+            </a:solidFill>
+            <a:prstDash val="solid"/>
+          </a:ln>
+        </p:spPr>
+      </p:sp>
+      <p:sp>
+        <p:nvSpPr>
+          <p:cNvPr id="34" name="Text 32"/>
+          <p:cNvSpPr/>
+          <p:nvPr/>
+        </p:nvSpPr>
+        <p:spPr>
+          <a:xfrm>
+            <a:off x="457200" y="4864608"/>
+            <a:ext cx="2743200" cy="228600"/>
+          </a:xfrm>
+          <a:prstGeom prst="rect">
+            <a:avLst/>
+          </a:prstGeom>
+          <a:noFill/>
+          <a:ln/>
+        </p:spPr>
+        <p:txBody>
+          <a:bodyPr wrap="square" lIns="0" tIns="0" rIns="0" bIns="0" rtlCol="0" anchor="ctr"/>
+          <a:lstStyle/>
+          <a:p>
+            <a:pPr indent="0" marL="0">
+              <a:buNone/>
+            </a:pPr>
+            <a:r>
+              <a:rPr lang="en-US" sz="800" b="1" spc="400" kern="0" dirty="0">
+                <a:solidFill>
+                  <a:srgbClr val="6E7699"/>
+                </a:solidFill>
+                <a:latin typeface="Space Grotesk" pitchFamily="34" charset="0"/>
+                <a:ea typeface="Space Grotesk" pitchFamily="34" charset="-122"/>
+                <a:cs typeface="Space Grotesk" pitchFamily="34" charset="-120"/>
+              </a:rPr>
               <a:t>ARCHITECT.DEV</a:t>
             </a:r>
             <a:endParaRPr lang="en-US" sz="800" dirty="0"/>
@@ -5494,7 +6351,7 @@
       </p:sp>
       <p:sp>
         <p:nvSpPr>
-          <p:cNvPr id="9" name="Text 6"/>
+          <p:cNvPr id="35" name="Text 33"/>
           <p:cNvSpPr/>
           <p:nvPr/>
         </p:nvSpPr>
@@ -6003,7 +6860,7 @@
                 <a:ea typeface="Courier New" pitchFamily="34" charset="-122"/>
                 <a:cs typeface="Courier New" pitchFamily="34" charset="-120"/>
               </a:rPr>
-              <a:t>items · cvs</a:t>
+              <a:t>items + overrides · cvs</a:t>
             </a:r>
             <a:endParaRPr lang="en-US" sz="1000" dirty="0"/>
           </a:p>
@@ -6170,7 +7027,7 @@
                 <a:ea typeface="Courier New" pitchFamily="34" charset="-122"/>
                 <a:cs typeface="Courier New" pitchFamily="34" charset="-120"/>
               </a:rPr>
-              <a:t>repos · profile</a:t>
+              <a:t>user profile</a:t>
             </a:r>
             <a:endParaRPr lang="en-US" sz="1000" dirty="0"/>
           </a:p>
@@ -6187,7 +7044,7 @@
                 <a:ea typeface="Courier New" pitchFamily="34" charset="-122"/>
                 <a:cs typeface="Courier New" pitchFamily="34" charset="-120"/>
               </a:rPr>
-              <a:t>portfolio.yaml (raw)</a:t>
+              <a:t>repos list</a:t>
             </a:r>
             <a:endParaRPr lang="en-US" sz="1000" dirty="0"/>
           </a:p>
@@ -6859,7 +7716,7 @@
                 <a:ea typeface="Space Grotesk" pitchFamily="34" charset="-122"/>
                 <a:cs typeface="Space Grotesk" pitchFamily="34" charset="-120"/>
               </a:rPr>
-              <a:t>~12 components</a:t>
+              <a:t>Small component tree</a:t>
             </a:r>
             <a:endParaRPr lang="en-US" sz="1300" dirty="0"/>
           </a:p>
@@ -6898,7 +7755,7 @@
                 <a:ea typeface="Inter" pitchFamily="34" charset="-122"/>
                 <a:cs typeface="Inter" pitchFamily="34" charset="-120"/>
               </a:rPr>
-              <a:t>Page-level: HomePage, UserPage, CvPage, MyPagesPage. Plus ProjectCard, UserTabs, CvEdit.</a:t>
+              <a:t>Four page files (HomePage · UserPage · CvPage · MyPagesPage) and a few shared leaves (ProjectCard · UserTabs · CvEdit).</a:t>
             </a:r>
             <a:endParaRPr lang="en-US" sz="1050" dirty="0"/>
           </a:p>
@@ -7496,7 +8353,7 @@
                 <a:ea typeface="Space Grotesk" pitchFamily="34" charset="-122"/>
                 <a:cs typeface="Space Grotesk" pitchFamily="34" charset="-120"/>
               </a:rPr>
-              <a:t>One hook per concern.</a:t>
+              <a:t>The hooks we use — with examples.</a:t>
             </a:r>
             <a:endParaRPr lang="en-US" sz="3200" dirty="0"/>
           </a:p>
@@ -7535,7 +8392,7 @@
                 <a:ea typeface="Inter" pitchFamily="34" charset="-122"/>
                 <a:cs typeface="Inter" pitchFamily="34" charset="-120"/>
               </a:rPr>
-              <a:t>Each part of the UI picks the smallest React primitive that solves its problem — no external state manager, no custom hook library.</a:t>
+              <a:t>A hook is a built-in function a component can call. Each card shows one hook, what it does in plain English, and exactly where it lives in this project.</a:t>
             </a:r>
             <a:endParaRPr lang="en-US" sz="1300" dirty="0"/>
           </a:p>
@@ -7549,8 +8406,8 @@
         </p:nvSpPr>
         <p:spPr>
           <a:xfrm>
-            <a:off x="457200" y="2286000"/>
-            <a:ext cx="2609088" cy="1065276"/>
+            <a:off x="457200" y="2194560"/>
+            <a:ext cx="2621280" cy="1211580"/>
           </a:xfrm>
           <a:prstGeom prst="rect">
             <a:avLst/>
@@ -7574,8 +8431,8 @@
         </p:nvSpPr>
         <p:spPr>
           <a:xfrm>
-            <a:off x="457200" y="2286000"/>
-            <a:ext cx="36576" cy="1065276"/>
+            <a:off x="457200" y="2194560"/>
+            <a:ext cx="36576" cy="1211580"/>
           </a:xfrm>
           <a:prstGeom prst="rect">
             <a:avLst/>
@@ -7599,8 +8456,8 @@
         </p:nvSpPr>
         <p:spPr>
           <a:xfrm>
-            <a:off x="621792" y="2395728"/>
-            <a:ext cx="2334768" cy="274320"/>
+            <a:off x="621792" y="2286000"/>
+            <a:ext cx="2346960" cy="228600"/>
           </a:xfrm>
           <a:prstGeom prst="rect">
             <a:avLst/>
@@ -7638,32 +8495,32 @@
         </p:nvSpPr>
         <p:spPr>
           <a:xfrm>
-            <a:off x="621792" y="2633472"/>
-            <a:ext cx="2334768" cy="201168"/>
-          </a:xfrm>
-          <a:prstGeom prst="rect">
-            <a:avLst/>
-          </a:prstGeom>
-          <a:noFill/>
-          <a:ln/>
-        </p:spPr>
-        <p:txBody>
-          <a:bodyPr wrap="square" lIns="0" tIns="0" rIns="0" bIns="0" rtlCol="0" anchor="ctr"/>
-          <a:lstStyle/>
-          <a:p>
-            <a:pPr indent="0" marL="0">
-              <a:buNone/>
-            </a:pPr>
-            <a:r>
-              <a:rPr lang="en-US" sz="900" b="1" spc="300" kern="0" dirty="0">
+            <a:off x="621792" y="2523744"/>
+            <a:ext cx="2346960" cy="182880"/>
+          </a:xfrm>
+          <a:prstGeom prst="rect">
+            <a:avLst/>
+          </a:prstGeom>
+          <a:noFill/>
+          <a:ln/>
+        </p:spPr>
+        <p:txBody>
+          <a:bodyPr wrap="square" lIns="0" tIns="0" rIns="0" bIns="0" rtlCol="0" anchor="ctr"/>
+          <a:lstStyle/>
+          <a:p>
+            <a:pPr indent="0" marL="0">
+              <a:buNone/>
+            </a:pPr>
+            <a:r>
+              <a:rPr lang="en-US" sz="900" dirty="0">
                 <a:solidFill>
                   <a:srgbClr val="6E7699"/>
                 </a:solidFill>
-                <a:latin typeface="Space Grotesk" pitchFamily="34" charset="0"/>
-                <a:ea typeface="Space Grotesk" pitchFamily="34" charset="-122"/>
-                <a:cs typeface="Space Grotesk" pitchFamily="34" charset="-120"/>
-              </a:rPr>
-              <a:t>pieces of truth</a:t>
+                <a:latin typeface="Courier New" pitchFamily="34" charset="0"/>
+                <a:ea typeface="Courier New" pitchFamily="34" charset="-122"/>
+                <a:cs typeface="Courier New" pitchFamily="34" charset="-120"/>
+              </a:rPr>
+              <a:t>HomePage.tsx</a:t>
             </a:r>
             <a:endParaRPr lang="en-US" sz="900" dirty="0"/>
           </a:p>
@@ -7677,24 +8534,24 @@
         </p:nvSpPr>
         <p:spPr>
           <a:xfrm>
-            <a:off x="621792" y="2834640"/>
-            <a:ext cx="2334768" cy="461772"/>
-          </a:xfrm>
-          <a:prstGeom prst="rect">
-            <a:avLst/>
-          </a:prstGeom>
-          <a:noFill/>
-          <a:ln/>
-        </p:spPr>
-        <p:txBody>
-          <a:bodyPr wrap="square" lIns="0" tIns="0" rIns="0" bIns="0" rtlCol="0" anchor="ctr"/>
-          <a:lstStyle/>
-          <a:p>
-            <a:pPr indent="0" marL="0">
-              <a:buNone/>
-            </a:pPr>
-            <a:r>
-              <a:rPr lang="en-US" sz="1000" dirty="0">
+            <a:off x="621792" y="2743200"/>
+            <a:ext cx="2346960" cy="571500"/>
+          </a:xfrm>
+          <a:prstGeom prst="rect">
+            <a:avLst/>
+          </a:prstGeom>
+          <a:noFill/>
+          <a:ln/>
+        </p:spPr>
+        <p:txBody>
+          <a:bodyPr wrap="square" lIns="0" tIns="0" rIns="0" bIns="0" rtlCol="0" anchor="ctr"/>
+          <a:lstStyle/>
+          <a:p>
+            <a:pPr indent="0" marL="0">
+              <a:buNone/>
+            </a:pPr>
+            <a:r>
+              <a:rPr lang="en-US" sz="950" dirty="0">
                 <a:solidFill>
                   <a:srgbClr val="A7ADC6"/>
                 </a:solidFill>
@@ -7702,9 +8559,9 @@
                 <a:ea typeface="Inter" pitchFamily="34" charset="-122"/>
                 <a:cs typeface="Inter" pitchFamily="34" charset="-120"/>
               </a:rPr>
-              <a:t>Holds session user, loaded page data, loading flags, and edit-form buffers. Each page owns the state it cares about.</a:t>
-            </a:r>
-            <a:endParaRPr lang="en-US" sz="1000" dirty="0"/>
+              <a:t>Holds a value that can change. Here: profiles starts as null, then becomes the list of users once Supabase replies.</a:t>
+            </a:r>
+            <a:endParaRPr lang="en-US" sz="950" dirty="0"/>
           </a:p>
         </p:txBody>
       </p:sp>
@@ -7716,8 +8573,8 @@
         </p:nvSpPr>
         <p:spPr>
           <a:xfrm>
-            <a:off x="3267456" y="2286000"/>
-            <a:ext cx="2609088" cy="1065276"/>
+            <a:off x="3261360" y="2194560"/>
+            <a:ext cx="2621280" cy="1211580"/>
           </a:xfrm>
           <a:prstGeom prst="rect">
             <a:avLst/>
@@ -7741,8 +8598,8 @@
         </p:nvSpPr>
         <p:spPr>
           <a:xfrm>
-            <a:off x="3267456" y="2286000"/>
-            <a:ext cx="36576" cy="1065276"/>
+            <a:off x="3261360" y="2194560"/>
+            <a:ext cx="36576" cy="1211580"/>
           </a:xfrm>
           <a:prstGeom prst="rect">
             <a:avLst/>
@@ -7766,8 +8623,8 @@
         </p:nvSpPr>
         <p:spPr>
           <a:xfrm>
-            <a:off x="3432048" y="2395728"/>
-            <a:ext cx="2334768" cy="274320"/>
+            <a:off x="3425952" y="2286000"/>
+            <a:ext cx="2346960" cy="228600"/>
           </a:xfrm>
           <a:prstGeom prst="rect">
             <a:avLst/>
@@ -7805,32 +8662,32 @@
         </p:nvSpPr>
         <p:spPr>
           <a:xfrm>
-            <a:off x="3432048" y="2633472"/>
-            <a:ext cx="2334768" cy="201168"/>
-          </a:xfrm>
-          <a:prstGeom prst="rect">
-            <a:avLst/>
-          </a:prstGeom>
-          <a:noFill/>
-          <a:ln/>
-        </p:spPr>
-        <p:txBody>
-          <a:bodyPr wrap="square" lIns="0" tIns="0" rIns="0" bIns="0" rtlCol="0" anchor="ctr"/>
-          <a:lstStyle/>
-          <a:p>
-            <a:pPr indent="0" marL="0">
-              <a:buNone/>
-            </a:pPr>
-            <a:r>
-              <a:rPr lang="en-US" sz="900" b="1" spc="300" kern="0" dirty="0">
+            <a:off x="3425952" y="2523744"/>
+            <a:ext cx="2346960" cy="182880"/>
+          </a:xfrm>
+          <a:prstGeom prst="rect">
+            <a:avLst/>
+          </a:prstGeom>
+          <a:noFill/>
+          <a:ln/>
+        </p:spPr>
+        <p:txBody>
+          <a:bodyPr wrap="square" lIns="0" tIns="0" rIns="0" bIns="0" rtlCol="0" anchor="ctr"/>
+          <a:lstStyle/>
+          <a:p>
+            <a:pPr indent="0" marL="0">
+              <a:buNone/>
+            </a:pPr>
+            <a:r>
+              <a:rPr lang="en-US" sz="900" dirty="0">
                 <a:solidFill>
                   <a:srgbClr val="6E7699"/>
                 </a:solidFill>
-                <a:latin typeface="Space Grotesk" pitchFamily="34" charset="0"/>
-                <a:ea typeface="Space Grotesk" pitchFamily="34" charset="-122"/>
-                <a:cs typeface="Space Grotesk" pitchFamily="34" charset="-120"/>
-              </a:rPr>
-              <a:t>load + cancel</a:t>
+                <a:latin typeface="Courier New" pitchFamily="34" charset="0"/>
+                <a:ea typeface="Courier New" pitchFamily="34" charset="-122"/>
+                <a:cs typeface="Courier New" pitchFamily="34" charset="-120"/>
+              </a:rPr>
+              <a:t>App.tsx</a:t>
             </a:r>
             <a:endParaRPr lang="en-US" sz="900" dirty="0"/>
           </a:p>
@@ -7844,24 +8701,24 @@
         </p:nvSpPr>
         <p:spPr>
           <a:xfrm>
-            <a:off x="3432048" y="2834640"/>
-            <a:ext cx="2334768" cy="461772"/>
-          </a:xfrm>
-          <a:prstGeom prst="rect">
-            <a:avLst/>
-          </a:prstGeom>
-          <a:noFill/>
-          <a:ln/>
-        </p:spPr>
-        <p:txBody>
-          <a:bodyPr wrap="square" lIns="0" tIns="0" rIns="0" bIns="0" rtlCol="0" anchor="ctr"/>
-          <a:lstStyle/>
-          <a:p>
-            <a:pPr indent="0" marL="0">
-              <a:buNone/>
-            </a:pPr>
-            <a:r>
-              <a:rPr lang="en-US" sz="1000" dirty="0">
+            <a:off x="3425952" y="2743200"/>
+            <a:ext cx="2346960" cy="571500"/>
+          </a:xfrm>
+          <a:prstGeom prst="rect">
+            <a:avLst/>
+          </a:prstGeom>
+          <a:noFill/>
+          <a:ln/>
+        </p:spPr>
+        <p:txBody>
+          <a:bodyPr wrap="square" lIns="0" tIns="0" rIns="0" bIns="0" rtlCol="0" anchor="ctr"/>
+          <a:lstStyle/>
+          <a:p>
+            <a:pPr indent="0" marL="0">
+              <a:buNone/>
+            </a:pPr>
+            <a:r>
+              <a:rPr lang="en-US" sz="950" dirty="0">
                 <a:solidFill>
                   <a:srgbClr val="A7ADC6"/>
                 </a:solidFill>
@@ -7869,9 +8726,9 @@
                 <a:ea typeface="Inter" pitchFamily="34" charset="-122"/>
                 <a:cs typeface="Inter" pitchFamily="34" charset="-120"/>
               </a:rPr>
-              <a:t>Kicks off async loaders on mount and when the URL changes. A cancelled flag in cleanup stops stale fetches from overwriting fresh ones.</a:t>
-            </a:r>
-            <a:endParaRPr lang="en-US" sz="1000" dirty="0"/>
+              <a:t>Runs code after render. Here: on mount we ask Supabase who's signed in, then subscribe to sign-in / sign-out events.</a:t>
+            </a:r>
+            <a:endParaRPr lang="en-US" sz="950" dirty="0"/>
           </a:p>
         </p:txBody>
       </p:sp>
@@ -7883,8 +8740,8 @@
         </p:nvSpPr>
         <p:spPr>
           <a:xfrm>
-            <a:off x="6077712" y="2286000"/>
-            <a:ext cx="2609088" cy="1065276"/>
+            <a:off x="6065520" y="2194560"/>
+            <a:ext cx="2621280" cy="1211580"/>
           </a:xfrm>
           <a:prstGeom prst="rect">
             <a:avLst/>
@@ -7908,8 +8765,8 @@
         </p:nvSpPr>
         <p:spPr>
           <a:xfrm>
-            <a:off x="6077712" y="2286000"/>
-            <a:ext cx="36576" cy="1065276"/>
+            <a:off x="6065520" y="2194560"/>
+            <a:ext cx="36576" cy="1211580"/>
           </a:xfrm>
           <a:prstGeom prst="rect">
             <a:avLst/>
@@ -7933,8 +8790,8 @@
         </p:nvSpPr>
         <p:spPr>
           <a:xfrm>
-            <a:off x="6242304" y="2395728"/>
-            <a:ext cx="2334768" cy="274320"/>
+            <a:off x="6230112" y="2286000"/>
+            <a:ext cx="2346960" cy="228600"/>
           </a:xfrm>
           <a:prstGeom prst="rect">
             <a:avLst/>
@@ -7972,32 +8829,32 @@
         </p:nvSpPr>
         <p:spPr>
           <a:xfrm>
-            <a:off x="6242304" y="2633472"/>
-            <a:ext cx="2334768" cy="201168"/>
-          </a:xfrm>
-          <a:prstGeom prst="rect">
-            <a:avLst/>
-          </a:prstGeom>
-          <a:noFill/>
-          <a:ln/>
-        </p:spPr>
-        <p:txBody>
-          <a:bodyPr wrap="square" lIns="0" tIns="0" rIns="0" bIns="0" rtlCol="0" anchor="ctr"/>
-          <a:lstStyle/>
-          <a:p>
-            <a:pPr indent="0" marL="0">
-              <a:buNone/>
-            </a:pPr>
-            <a:r>
-              <a:rPr lang="en-US" sz="900" b="1" spc="300" kern="0" dirty="0">
+            <a:off x="6230112" y="2523744"/>
+            <a:ext cx="2346960" cy="182880"/>
+          </a:xfrm>
+          <a:prstGeom prst="rect">
+            <a:avLst/>
+          </a:prstGeom>
+          <a:noFill/>
+          <a:ln/>
+        </p:spPr>
+        <p:txBody>
+          <a:bodyPr wrap="square" lIns="0" tIns="0" rIns="0" bIns="0" rtlCol="0" anchor="ctr"/>
+          <a:lstStyle/>
+          <a:p>
+            <a:pPr indent="0" marL="0">
+              <a:buNone/>
+            </a:pPr>
+            <a:r>
+              <a:rPr lang="en-US" sz="900" dirty="0">
                 <a:solidFill>
                   <a:srgbClr val="6E7699"/>
                 </a:solidFill>
-                <a:latin typeface="Space Grotesk" pitchFamily="34" charset="0"/>
-                <a:ea typeface="Space Grotesk" pitchFamily="34" charset="-122"/>
-                <a:cs typeface="Space Grotesk" pitchFamily="34" charset="-120"/>
-              </a:rPr>
-              <a:t>derived buckets</a:t>
+                <a:latin typeface="Courier New" pitchFamily="34" charset="0"/>
+                <a:ea typeface="Courier New" pitchFamily="34" charset="-122"/>
+                <a:cs typeface="Courier New" pitchFamily="34" charset="-120"/>
+              </a:rPr>
+              <a:t>UserPage.tsx</a:t>
             </a:r>
             <a:endParaRPr lang="en-US" sz="900" dirty="0"/>
           </a:p>
@@ -8011,24 +8868,24 @@
         </p:nvSpPr>
         <p:spPr>
           <a:xfrm>
-            <a:off x="6242304" y="2834640"/>
-            <a:ext cx="2334768" cy="461772"/>
-          </a:xfrm>
-          <a:prstGeom prst="rect">
-            <a:avLst/>
-          </a:prstGeom>
-          <a:noFill/>
-          <a:ln/>
-        </p:spPr>
-        <p:txBody>
-          <a:bodyPr wrap="square" lIns="0" tIns="0" rIns="0" bIns="0" rtlCol="0" anchor="ctr"/>
-          <a:lstStyle/>
-          <a:p>
-            <a:pPr indent="0" marL="0">
-              <a:buNone/>
-            </a:pPr>
-            <a:r>
-              <a:rPr lang="en-US" sz="1000" dirty="0">
+            <a:off x="6230112" y="2743200"/>
+            <a:ext cx="2346960" cy="571500"/>
+          </a:xfrm>
+          <a:prstGeom prst="rect">
+            <a:avLst/>
+          </a:prstGeom>
+          <a:noFill/>
+          <a:ln/>
+        </p:spPr>
+        <p:txBody>
+          <a:bodyPr wrap="square" lIns="0" tIns="0" rIns="0" bIns="0" rtlCol="0" anchor="ctr"/>
+          <a:lstStyle/>
+          <a:p>
+            <a:pPr indent="0" marL="0">
+              <a:buNone/>
+            </a:pPr>
+            <a:r>
+              <a:rPr lang="en-US" sz="950" dirty="0">
                 <a:solidFill>
                   <a:srgbClr val="A7ADC6"/>
                 </a:solidFill>
@@ -8036,9 +8893,9 @@
                 <a:ea typeface="Inter" pitchFamily="34" charset="-122"/>
                 <a:cs typeface="Inter" pitchFamily="34" charset="-120"/>
               </a:rPr>
-              <a:t>Groups the flat Project list into folders + unfiled + hidden. Recomputes only when projects or folder definitions change.</a:t>
-            </a:r>
-            <a:endParaRPr lang="en-US" sz="1000" dirty="0"/>
+              <a:t>Caches a calculation. Here: buildBuckets(data) groups projects into Featured + folders — only re-runs when data changes.</a:t>
+            </a:r>
+            <a:endParaRPr lang="en-US" sz="950" dirty="0"/>
           </a:p>
         </p:txBody>
       </p:sp>
@@ -8050,8 +8907,8 @@
         </p:nvSpPr>
         <p:spPr>
           <a:xfrm>
-            <a:off x="457200" y="3552444"/>
-            <a:ext cx="2609088" cy="1065276"/>
+            <a:off x="457200" y="3589020"/>
+            <a:ext cx="2621280" cy="1211580"/>
           </a:xfrm>
           <a:prstGeom prst="rect">
             <a:avLst/>
@@ -8075,8 +8932,8 @@
         </p:nvSpPr>
         <p:spPr>
           <a:xfrm>
-            <a:off x="457200" y="3552444"/>
-            <a:ext cx="36576" cy="1065276"/>
+            <a:off x="457200" y="3589020"/>
+            <a:ext cx="36576" cy="1211580"/>
           </a:xfrm>
           <a:prstGeom prst="rect">
             <a:avLst/>
@@ -8100,8 +8957,8 @@
         </p:nvSpPr>
         <p:spPr>
           <a:xfrm>
-            <a:off x="621792" y="3662172"/>
-            <a:ext cx="2334768" cy="274320"/>
+            <a:off x="621792" y="3680460"/>
+            <a:ext cx="2346960" cy="228600"/>
           </a:xfrm>
           <a:prstGeom prst="rect">
             <a:avLst/>
@@ -8139,32 +8996,32 @@
         </p:nvSpPr>
         <p:spPr>
           <a:xfrm>
-            <a:off x="621792" y="3899916"/>
-            <a:ext cx="2334768" cy="201168"/>
-          </a:xfrm>
-          <a:prstGeom prst="rect">
-            <a:avLst/>
-          </a:prstGeom>
-          <a:noFill/>
-          <a:ln/>
-        </p:spPr>
-        <p:txBody>
-          <a:bodyPr wrap="square" lIns="0" tIns="0" rIns="0" bIns="0" rtlCol="0" anchor="ctr"/>
-          <a:lstStyle/>
-          <a:p>
-            <a:pPr indent="0" marL="0">
-              <a:buNone/>
-            </a:pPr>
-            <a:r>
-              <a:rPr lang="en-US" sz="900" b="1" spc="300" kern="0" dirty="0">
+            <a:off x="621792" y="3918204"/>
+            <a:ext cx="2346960" cy="182880"/>
+          </a:xfrm>
+          <a:prstGeom prst="rect">
+            <a:avLst/>
+          </a:prstGeom>
+          <a:noFill/>
+          <a:ln/>
+        </p:spPr>
+        <p:txBody>
+          <a:bodyPr wrap="square" lIns="0" tIns="0" rIns="0" bIns="0" rtlCol="0" anchor="ctr"/>
+          <a:lstStyle/>
+          <a:p>
+            <a:pPr indent="0" marL="0">
+              <a:buNone/>
+            </a:pPr>
+            <a:r>
+              <a:rPr lang="en-US" sz="900" dirty="0">
                 <a:solidFill>
                   <a:srgbClr val="6E7699"/>
                 </a:solidFill>
-                <a:latin typeface="Space Grotesk" pitchFamily="34" charset="0"/>
-                <a:ea typeface="Space Grotesk" pitchFamily="34" charset="-122"/>
-                <a:cs typeface="Space Grotesk" pitchFamily="34" charset="-120"/>
-              </a:rPr>
-              <a:t>snappy edits</a:t>
+                <a:latin typeface="Courier New" pitchFamily="34" charset="0"/>
+                <a:ea typeface="Courier New" pitchFamily="34" charset="-122"/>
+                <a:cs typeface="Courier New" pitchFamily="34" charset="-120"/>
+              </a:rPr>
+              <a:t>UserPage.tsx</a:t>
             </a:r>
             <a:endParaRPr lang="en-US" sz="900" dirty="0"/>
           </a:p>
@@ -8178,24 +9035,24 @@
         </p:nvSpPr>
         <p:spPr>
           <a:xfrm>
-            <a:off x="621792" y="4101084"/>
-            <a:ext cx="2334768" cy="461772"/>
-          </a:xfrm>
-          <a:prstGeom prst="rect">
-            <a:avLst/>
-          </a:prstGeom>
-          <a:noFill/>
-          <a:ln/>
-        </p:spPr>
-        <p:txBody>
-          <a:bodyPr wrap="square" lIns="0" tIns="0" rIns="0" bIns="0" rtlCol="0" anchor="ctr"/>
-          <a:lstStyle/>
-          <a:p>
-            <a:pPr indent="0" marL="0">
-              <a:buNone/>
-            </a:pPr>
-            <a:r>
-              <a:rPr lang="en-US" sz="1000" dirty="0">
+            <a:off x="621792" y="4137660"/>
+            <a:ext cx="2346960" cy="571500"/>
+          </a:xfrm>
+          <a:prstGeom prst="rect">
+            <a:avLst/>
+          </a:prstGeom>
+          <a:noFill/>
+          <a:ln/>
+        </p:spPr>
+        <p:txBody>
+          <a:bodyPr wrap="square" lIns="0" tIns="0" rIns="0" bIns="0" rtlCol="0" anchor="ctr"/>
+          <a:lstStyle/>
+          <a:p>
+            <a:pPr indent="0" marL="0">
+              <a:buNone/>
+            </a:pPr>
+            <a:r>
+              <a:rPr lang="en-US" sz="950" dirty="0">
                 <a:solidFill>
                   <a:srgbClr val="A7ADC6"/>
                 </a:solidFill>
@@ -8203,9 +9060,9 @@
                 <a:ea typeface="Inter" pitchFamily="34" charset="-122"/>
                 <a:cs typeface="Inter" pitchFamily="34" charset="-120"/>
               </a:rPr>
-              <a:t>Drag-reorders and visibility toggles are marked low-priority, so the UI updates instantly while Supabase writes happen in the background.</a:t>
-            </a:r>
-            <a:endParaRPr lang="en-US" sz="1000" dirty="0"/>
+              <a:t>Marks an update as low-priority. Here: dragging a project reorders the UI instantly; the Supabase save runs inside startTransition.</a:t>
+            </a:r>
+            <a:endParaRPr lang="en-US" sz="950" dirty="0"/>
           </a:p>
         </p:txBody>
       </p:sp>
@@ -8217,8 +9074,8 @@
         </p:nvSpPr>
         <p:spPr>
           <a:xfrm>
-            <a:off x="3267456" y="3552444"/>
-            <a:ext cx="2609088" cy="1065276"/>
+            <a:off x="3261360" y="3589020"/>
+            <a:ext cx="2621280" cy="1211580"/>
           </a:xfrm>
           <a:prstGeom prst="rect">
             <a:avLst/>
@@ -8242,8 +9099,8 @@
         </p:nvSpPr>
         <p:spPr>
           <a:xfrm>
-            <a:off x="3267456" y="3552444"/>
-            <a:ext cx="36576" cy="1065276"/>
+            <a:off x="3261360" y="3589020"/>
+            <a:ext cx="36576" cy="1211580"/>
           </a:xfrm>
           <a:prstGeom prst="rect">
             <a:avLst/>
@@ -8267,8 +9124,8 @@
         </p:nvSpPr>
         <p:spPr>
           <a:xfrm>
-            <a:off x="3432048" y="3662172"/>
-            <a:ext cx="2334768" cy="274320"/>
+            <a:off x="3425952" y="3680460"/>
+            <a:ext cx="2346960" cy="228600"/>
           </a:xfrm>
           <a:prstGeom prst="rect">
             <a:avLst/>
@@ -8306,32 +9163,32 @@
         </p:nvSpPr>
         <p:spPr>
           <a:xfrm>
-            <a:off x="3432048" y="3899916"/>
-            <a:ext cx="2334768" cy="201168"/>
-          </a:xfrm>
-          <a:prstGeom prst="rect">
-            <a:avLst/>
-          </a:prstGeom>
-          <a:noFill/>
-          <a:ln/>
-        </p:spPr>
-        <p:txBody>
-          <a:bodyPr wrap="square" lIns="0" tIns="0" rIns="0" bIns="0" rtlCol="0" anchor="ctr"/>
-          <a:lstStyle/>
-          <a:p>
-            <a:pPr indent="0" marL="0">
-              <a:buNone/>
-            </a:pPr>
-            <a:r>
-              <a:rPr lang="en-US" sz="900" b="1" spc="300" kern="0" dirty="0">
+            <a:off x="3425952" y="3918204"/>
+            <a:ext cx="2346960" cy="182880"/>
+          </a:xfrm>
+          <a:prstGeom prst="rect">
+            <a:avLst/>
+          </a:prstGeom>
+          <a:noFill/>
+          <a:ln/>
+        </p:spPr>
+        <p:txBody>
+          <a:bodyPr wrap="square" lIns="0" tIns="0" rIns="0" bIns="0" rtlCol="0" anchor="ctr"/>
+          <a:lstStyle/>
+          <a:p>
+            <a:pPr indent="0" marL="0">
+              <a:buNone/>
+            </a:pPr>
+            <a:r>
+              <a:rPr lang="en-US" sz="900" dirty="0">
                 <a:solidFill>
                   <a:srgbClr val="6E7699"/>
                 </a:solidFill>
-                <a:latin typeface="Space Grotesk" pitchFamily="34" charset="0"/>
-                <a:ea typeface="Space Grotesk" pitchFamily="34" charset="-122"/>
-                <a:cs typeface="Space Grotesk" pitchFamily="34" charset="-120"/>
-              </a:rPr>
-              <a:t>URL as state</a:t>
+                <a:latin typeface="Courier New" pitchFamily="34" charset="0"/>
+                <a:ea typeface="Courier New" pitchFamily="34" charset="-122"/>
+                <a:cs typeface="Courier New" pitchFamily="34" charset="-120"/>
+              </a:rPr>
+              <a:t>App.tsx</a:t>
             </a:r>
             <a:endParaRPr lang="en-US" sz="900" dirty="0"/>
           </a:p>
@@ -8345,24 +9202,24 @@
         </p:nvSpPr>
         <p:spPr>
           <a:xfrm>
-            <a:off x="3432048" y="4101084"/>
-            <a:ext cx="2334768" cy="461772"/>
-          </a:xfrm>
-          <a:prstGeom prst="rect">
-            <a:avLst/>
-          </a:prstGeom>
-          <a:noFill/>
-          <a:ln/>
-        </p:spPr>
-        <p:txBody>
-          <a:bodyPr wrap="square" lIns="0" tIns="0" rIns="0" bIns="0" rtlCol="0" anchor="ctr"/>
-          <a:lstStyle/>
-          <a:p>
-            <a:pPr indent="0" marL="0">
-              <a:buNone/>
-            </a:pPr>
-            <a:r>
-              <a:rPr lang="en-US" sz="1000" dirty="0">
+            <a:off x="3425952" y="4137660"/>
+            <a:ext cx="2346960" cy="571500"/>
+          </a:xfrm>
+          <a:prstGeom prst="rect">
+            <a:avLst/>
+          </a:prstGeom>
+          <a:noFill/>
+          <a:ln/>
+        </p:spPr>
+        <p:txBody>
+          <a:bodyPr wrap="square" lIns="0" tIns="0" rIns="0" bIns="0" rtlCol="0" anchor="ctr"/>
+          <a:lstStyle/>
+          <a:p>
+            <a:pPr indent="0" marL="0">
+              <a:buNone/>
+            </a:pPr>
+            <a:r>
+              <a:rPr lang="en-US" sz="950" dirty="0">
                 <a:solidFill>
                   <a:srgbClr val="A7ADC6"/>
                 </a:solidFill>
@@ -8370,9 +9227,9 @@
                 <a:ea typeface="Inter" pitchFamily="34" charset="-122"/>
                 <a:cs typeface="Inter" pitchFamily="34" charset="-120"/>
               </a:rPr>
-              <a:t>Subscribes to hashchange. Turns the URL fragment into a normal React value — no react-router dependency.</a:t>
-            </a:r>
-            <a:endParaRPr lang="en-US" sz="1000" dirty="0"/>
+              <a:t>Reads something outside React as state. Here: the URL hash — so #/u/gusbo9233 triggers a render. No router library needed.</a:t>
+            </a:r>
+            <a:endParaRPr lang="en-US" sz="950" dirty="0"/>
           </a:p>
         </p:txBody>
       </p:sp>
@@ -8384,8 +9241,8 @@
         </p:nvSpPr>
         <p:spPr>
           <a:xfrm>
-            <a:off x="6077712" y="3552444"/>
-            <a:ext cx="2609088" cy="1065276"/>
+            <a:off x="6065520" y="3589020"/>
+            <a:ext cx="2621280" cy="1211580"/>
           </a:xfrm>
           <a:prstGeom prst="rect">
             <a:avLst/>
@@ -8409,8 +9266,8 @@
         </p:nvSpPr>
         <p:spPr>
           <a:xfrm>
-            <a:off x="6077712" y="3552444"/>
-            <a:ext cx="36576" cy="1065276"/>
+            <a:off x="6065520" y="3589020"/>
+            <a:ext cx="36576" cy="1211580"/>
           </a:xfrm>
           <a:prstGeom prst="rect">
             <a:avLst/>
@@ -8434,8 +9291,8 @@
         </p:nvSpPr>
         <p:spPr>
           <a:xfrm>
-            <a:off x="6242304" y="3662172"/>
-            <a:ext cx="2334768" cy="274320"/>
+            <a:off x="6230112" y="3680460"/>
+            <a:ext cx="2346960" cy="228600"/>
           </a:xfrm>
           <a:prstGeom prst="rect">
             <a:avLst/>
@@ -8473,32 +9330,32 @@
         </p:nvSpPr>
         <p:spPr>
           <a:xfrm>
-            <a:off x="6242304" y="3899916"/>
-            <a:ext cx="2334768" cy="201168"/>
-          </a:xfrm>
-          <a:prstGeom prst="rect">
-            <a:avLst/>
-          </a:prstGeom>
-          <a:noFill/>
-          <a:ln/>
-        </p:spPr>
-        <p:txBody>
-          <a:bodyPr wrap="square" lIns="0" tIns="0" rIns="0" bIns="0" rtlCol="0" anchor="ctr"/>
-          <a:lstStyle/>
-          <a:p>
-            <a:pPr indent="0" marL="0">
-              <a:buNone/>
-            </a:pPr>
-            <a:r>
-              <a:rPr lang="en-US" sz="900" b="1" spc="300" kern="0" dirty="0">
+            <a:off x="6230112" y="3918204"/>
+            <a:ext cx="2346960" cy="182880"/>
+          </a:xfrm>
+          <a:prstGeom prst="rect">
+            <a:avLst/>
+          </a:prstGeom>
+          <a:noFill/>
+          <a:ln/>
+        </p:spPr>
+        <p:txBody>
+          <a:bodyPr wrap="square" lIns="0" tIns="0" rIns="0" bIns="0" rtlCol="0" anchor="ctr"/>
+          <a:lstStyle/>
+          <a:p>
+            <a:pPr indent="0" marL="0">
+              <a:buNone/>
+            </a:pPr>
+            <a:r>
+              <a:rPr lang="en-US" sz="900" dirty="0">
                 <a:solidFill>
                   <a:srgbClr val="6E7699"/>
                 </a:solidFill>
-                <a:latin typeface="Space Grotesk" pitchFamily="34" charset="0"/>
-                <a:ea typeface="Space Grotesk" pitchFamily="34" charset="-122"/>
-                <a:cs typeface="Space Grotesk" pitchFamily="34" charset="-120"/>
-              </a:rPr>
-              <a:t>reader vs owner</a:t>
+                <a:latin typeface="Courier New" pitchFamily="34" charset="0"/>
+                <a:ea typeface="Courier New" pitchFamily="34" charset="-122"/>
+                <a:cs typeface="Courier New" pitchFamily="34" charset="-120"/>
+              </a:rPr>
+              <a:t>UserPage.tsx</a:t>
             </a:r>
             <a:endParaRPr lang="en-US" sz="900" dirty="0"/>
           </a:p>
@@ -8512,24 +9369,24 @@
         </p:nvSpPr>
         <p:spPr>
           <a:xfrm>
-            <a:off x="6242304" y="4101084"/>
-            <a:ext cx="2334768" cy="461772"/>
-          </a:xfrm>
-          <a:prstGeom prst="rect">
-            <a:avLst/>
-          </a:prstGeom>
-          <a:noFill/>
-          <a:ln/>
-        </p:spPr>
-        <p:txBody>
-          <a:bodyPr wrap="square" lIns="0" tIns="0" rIns="0" bIns="0" rtlCol="0" anchor="ctr"/>
-          <a:lstStyle/>
-          <a:p>
-            <a:pPr indent="0" marL="0">
-              <a:buNone/>
-            </a:pPr>
-            <a:r>
-              <a:rPr lang="en-US" sz="1000" dirty="0">
+            <a:off x="6230112" y="4137660"/>
+            <a:ext cx="2346960" cy="571500"/>
+          </a:xfrm>
+          <a:prstGeom prst="rect">
+            <a:avLst/>
+          </a:prstGeom>
+          <a:noFill/>
+          <a:ln/>
+        </p:spPr>
+        <p:txBody>
+          <a:bodyPr wrap="square" lIns="0" tIns="0" rIns="0" bIns="0" rtlCol="0" anchor="ctr"/>
+          <a:lstStyle/>
+          <a:p>
+            <a:pPr indent="0" marL="0">
+              <a:buNone/>
+            </a:pPr>
+            <a:r>
+              <a:rPr lang="en-US" sz="950" dirty="0">
                 <a:solidFill>
                   <a:srgbClr val="A7ADC6"/>
                 </a:solidFill>
@@ -8537,9 +9394,9 @@
                 <a:ea typeface="Inter" pitchFamily="34" charset="-122"/>
                 <a:cs typeface="Inter" pitchFamily="34" charset="-120"/>
               </a:rPr>
-              <a:t>One page component owns loading; ReaderView and OwnerView swap in based on auth; ProjectCard is the shared leaf.</a:t>
-            </a:r>
-            <a:endParaRPr lang="en-US" sz="1000" dirty="0"/>
+              <a:t>Small parts, bigger whole. UserPage picks ReaderView or OwnerView depending on who's viewing; both share the same ProjectCard.</a:t>
+            </a:r>
+            <a:endParaRPr lang="en-US" sz="950" dirty="0"/>
           </a:p>
         </p:txBody>
       </p:sp>
@@ -9878,7 +10735,7 @@
                 <a:ea typeface="Space Grotesk" pitchFamily="34" charset="-122"/>
                 <a:cs typeface="Space Grotesk" pitchFamily="34" charset="-120"/>
               </a:rPr>
-              <a:t>GitHub API +</a:t>
+              <a:t>GitHub facts +</a:t>
             </a:r>
             <a:endParaRPr lang="en-US" sz="3000" dirty="0"/>
           </a:p>
@@ -9895,7 +10752,7 @@
                 <a:ea typeface="Space Grotesk" pitchFamily="34" charset="-122"/>
                 <a:cs typeface="Space Grotesk" pitchFamily="34" charset="-120"/>
               </a:rPr>
-              <a:t>portfolio.yaml.</a:t>
+              <a:t>owner overrides.</a:t>
             </a:r>
             <a:endParaRPr lang="en-US" sz="3000" dirty="0"/>
           </a:p>
@@ -9998,7 +10855,7 @@
                 <a:ea typeface="Courier New" pitchFamily="34" charset="-122"/>
                 <a:cs typeface="Courier New" pitchFamily="34" charset="-120"/>
               </a:rPr>
-              <a:t>/users/{name}</a:t>
+              <a:t>GET /users/{name}</a:t>
             </a:r>
             <a:endParaRPr lang="en-US" sz="1050" dirty="0"/>
           </a:p>
@@ -10062,7 +10919,7 @@
                 <a:ea typeface="Courier New" pitchFamily="34" charset="-122"/>
                 <a:cs typeface="Courier New" pitchFamily="34" charset="-120"/>
               </a:rPr>
-              <a:t>/users/{name}/repos</a:t>
+              <a:t>GET /users/{name}/repos</a:t>
             </a:r>
             <a:endParaRPr lang="en-US" sz="1050" dirty="0"/>
           </a:p>
@@ -10126,7 +10983,7 @@
                 <a:ea typeface="Courier New" pitchFamily="34" charset="-122"/>
                 <a:cs typeface="Courier New" pitchFamily="34" charset="-120"/>
               </a:rPr>
-              <a:t>raw.githubusercontent.com/.../portfolio.yaml</a:t>
+              <a:t>supabase: portfolio_items</a:t>
             </a:r>
             <a:endParaRPr lang="en-US" sz="1050" dirty="0"/>
           </a:p>
@@ -10165,7 +11022,7 @@
                 <a:ea typeface="Inter" pitchFamily="34" charset="-122"/>
                 <a:cs typeface="Inter" pitchFamily="34" charset="-120"/>
               </a:rPr>
-              <a:t>Parsed with the yaml npm package. Forks are filtered; repos are sorted by stars then recency.</a:t>
+              <a:t>Forks are filtered out; repos are sorted by stars, then recency, before being merged with each user's overrides.</a:t>
             </a:r>
             <a:endParaRPr lang="en-US" sz="1100" dirty="0"/>
           </a:p>
@@ -10388,7 +11245,7 @@
                 <a:ea typeface="Space Grotesk" pitchFamily="34" charset="-122"/>
                 <a:cs typeface="Space Grotesk" pitchFamily="34" charset="-120"/>
               </a:rPr>
-              <a:t>portfolio.yaml</a:t>
+              <a:t>DB override</a:t>
             </a:r>
             <a:endParaRPr lang="en-US" sz="1000" dirty="0"/>
           </a:p>
@@ -10427,7 +11284,7 @@
                 <a:ea typeface="Courier New" pitchFamily="34" charset="-122"/>
                 <a:cs typeface="Courier New" pitchFamily="34" charset="-120"/>
               </a:rPr>
-              <a:t>title · description</a:t>
+              <a:t>title_override</a:t>
             </a:r>
             <a:endParaRPr lang="en-US" sz="900" dirty="0"/>
           </a:p>
@@ -10444,7 +11301,7 @@
                 <a:ea typeface="Courier New" pitchFamily="34" charset="-122"/>
                 <a:cs typeface="Courier New" pitchFamily="34" charset="-120"/>
               </a:rPr>
-              <a:t>tags[]</a:t>
+              <a:t>description_override</a:t>
             </a:r>
             <a:endParaRPr lang="en-US" sz="900" dirty="0"/>
           </a:p>
@@ -10586,7 +11443,7 @@
                 <a:ea typeface="Inter" pitchFamily="34" charset="-122"/>
                 <a:cs typeface="Inter" pitchFamily="34" charset="-120"/>
               </a:rPr>
-              <a:t>YAML fields win · GitHub fills the gaps</a:t>
+              <a:t>Overrides win · GitHub fills the gaps</a:t>
             </a:r>
             <a:endParaRPr lang="en-US" sz="1050" dirty="0"/>
           </a:p>
@@ -10917,24 +11774,24 @@
         </p:nvSpPr>
         <p:spPr>
           <a:xfrm>
-            <a:off x="777240" y="2606040"/>
-            <a:ext cx="2103120" cy="201168"/>
-          </a:xfrm>
-          <a:prstGeom prst="rect">
-            <a:avLst/>
-          </a:prstGeom>
-          <a:noFill/>
-          <a:ln/>
-        </p:spPr>
-        <p:txBody>
-          <a:bodyPr wrap="square" lIns="0" tIns="0" rIns="0" bIns="0" rtlCol="0" anchor="ctr"/>
-          <a:lstStyle/>
-          <a:p>
-            <a:pPr indent="0" marL="0">
-              <a:buNone/>
-            </a:pPr>
-            <a:r>
-              <a:rPr lang="en-US" sz="1050" b="1" dirty="0">
+            <a:off x="685800" y="2560320"/>
+            <a:ext cx="2377440" cy="155448"/>
+          </a:xfrm>
+          <a:prstGeom prst="rect">
+            <a:avLst/>
+          </a:prstGeom>
+          <a:noFill/>
+          <a:ln/>
+        </p:spPr>
+        <p:txBody>
+          <a:bodyPr wrap="square" lIns="0" tIns="0" rIns="0" bIns="0" rtlCol="0" anchor="ctr"/>
+          <a:lstStyle/>
+          <a:p>
+            <a:pPr indent="0" marL="0">
+              <a:buNone/>
+            </a:pPr>
+            <a:r>
+              <a:rPr lang="en-US" sz="950" b="1" dirty="0">
                 <a:solidFill>
                   <a:srgbClr val="C0C1FF"/>
                 </a:solidFill>
@@ -10944,7 +11801,7 @@
               </a:rPr>
               <a:t>App.tsx</a:t>
             </a:r>
-            <a:endParaRPr lang="en-US" sz="1050" dirty="0"/>
+            <a:endParaRPr lang="en-US" sz="950" dirty="0"/>
           </a:p>
         </p:txBody>
       </p:sp>
@@ -10956,24 +11813,24 @@
         </p:nvSpPr>
         <p:spPr>
           <a:xfrm>
-            <a:off x="2880360" y="2606040"/>
-            <a:ext cx="2194560" cy="201168"/>
-          </a:xfrm>
-          <a:prstGeom prst="rect">
-            <a:avLst/>
-          </a:prstGeom>
-          <a:noFill/>
-          <a:ln/>
-        </p:spPr>
-        <p:txBody>
-          <a:bodyPr wrap="square" lIns="0" tIns="0" rIns="0" bIns="0" rtlCol="0" anchor="ctr"/>
-          <a:lstStyle/>
-          <a:p>
-            <a:pPr indent="0" marL="0">
-              <a:buNone/>
-            </a:pPr>
-            <a:r>
-              <a:rPr lang="en-US" sz="1000" dirty="0">
+            <a:off x="3063240" y="2560320"/>
+            <a:ext cx="2011680" cy="155448"/>
+          </a:xfrm>
+          <a:prstGeom prst="rect">
+            <a:avLst/>
+          </a:prstGeom>
+          <a:noFill/>
+          <a:ln/>
+        </p:spPr>
+        <p:txBody>
+          <a:bodyPr wrap="square" lIns="0" tIns="0" rIns="0" bIns="0" rtlCol="0" anchor="ctr"/>
+          <a:lstStyle/>
+          <a:p>
+            <a:pPr indent="0" marL="0">
+              <a:buNone/>
+            </a:pPr>
+            <a:r>
+              <a:rPr lang="en-US" sz="900" dirty="0">
                 <a:solidFill>
                   <a:srgbClr val="A7ADC6"/>
                 </a:solidFill>
@@ -10981,9 +11838,9 @@
                 <a:ea typeface="Inter" pitchFamily="34" charset="-122"/>
                 <a:cs typeface="Inter" pitchFamily="34" charset="-120"/>
               </a:rPr>
-              <a:t>routing shell</a:t>
-            </a:r>
-            <a:endParaRPr lang="en-US" sz="1000" dirty="0"/>
+              <a:t>routing shell + auth</a:t>
+            </a:r>
+            <a:endParaRPr lang="en-US" sz="900" dirty="0"/>
           </a:p>
         </p:txBody>
       </p:sp>
@@ -10995,24 +11852,24 @@
         </p:nvSpPr>
         <p:spPr>
           <a:xfrm>
-            <a:off x="777240" y="2807208"/>
-            <a:ext cx="2103120" cy="201168"/>
-          </a:xfrm>
-          <a:prstGeom prst="rect">
-            <a:avLst/>
-          </a:prstGeom>
-          <a:noFill/>
-          <a:ln/>
-        </p:spPr>
-        <p:txBody>
-          <a:bodyPr wrap="square" lIns="0" tIns="0" rIns="0" bIns="0" rtlCol="0" anchor="ctr"/>
-          <a:lstStyle/>
-          <a:p>
-            <a:pPr indent="0" marL="0">
-              <a:buNone/>
-            </a:pPr>
-            <a:r>
-              <a:rPr lang="en-US" sz="1050" b="1" dirty="0">
+            <a:off x="685800" y="2715768"/>
+            <a:ext cx="2377440" cy="155448"/>
+          </a:xfrm>
+          <a:prstGeom prst="rect">
+            <a:avLst/>
+          </a:prstGeom>
+          <a:noFill/>
+          <a:ln/>
+        </p:spPr>
+        <p:txBody>
+          <a:bodyPr wrap="square" lIns="0" tIns="0" rIns="0" bIns="0" rtlCol="0" anchor="ctr"/>
+          <a:lstStyle/>
+          <a:p>
+            <a:pPr indent="0" marL="0">
+              <a:buNone/>
+            </a:pPr>
+            <a:r>
+              <a:rPr lang="en-US" sz="950" b="1" dirty="0">
                 <a:solidFill>
                   <a:srgbClr val="C0C1FF"/>
                 </a:solidFill>
@@ -11020,9 +11877,9 @@
                 <a:ea typeface="Courier New" pitchFamily="34" charset="-122"/>
                 <a:cs typeface="Courier New" pitchFamily="34" charset="-120"/>
               </a:rPr>
-              <a:t>HomePage.tsx</a:t>
-            </a:r>
-            <a:endParaRPr lang="en-US" sz="1050" dirty="0"/>
+              <a:t>CvEdit.tsx</a:t>
+            </a:r>
+            <a:endParaRPr lang="en-US" sz="950" dirty="0"/>
           </a:p>
         </p:txBody>
       </p:sp>
@@ -11034,24 +11891,24 @@
         </p:nvSpPr>
         <p:spPr>
           <a:xfrm>
-            <a:off x="2880360" y="2807208"/>
-            <a:ext cx="2194560" cy="201168"/>
-          </a:xfrm>
-          <a:prstGeom prst="rect">
-            <a:avLst/>
-          </a:prstGeom>
-          <a:noFill/>
-          <a:ln/>
-        </p:spPr>
-        <p:txBody>
-          <a:bodyPr wrap="square" lIns="0" tIns="0" rIns="0" bIns="0" rtlCol="0" anchor="ctr"/>
-          <a:lstStyle/>
-          <a:p>
-            <a:pPr indent="0" marL="0">
-              <a:buNone/>
-            </a:pPr>
-            <a:r>
-              <a:rPr lang="en-US" sz="1000" dirty="0">
+            <a:off x="3063240" y="2715768"/>
+            <a:ext cx="2011680" cy="155448"/>
+          </a:xfrm>
+          <a:prstGeom prst="rect">
+            <a:avLst/>
+          </a:prstGeom>
+          <a:noFill/>
+          <a:ln/>
+        </p:spPr>
+        <p:txBody>
+          <a:bodyPr wrap="square" lIns="0" tIns="0" rIns="0" bIns="0" rtlCol="0" anchor="ctr"/>
+          <a:lstStyle/>
+          <a:p>
+            <a:pPr indent="0" marL="0">
+              <a:buNone/>
+            </a:pPr>
+            <a:r>
+              <a:rPr lang="en-US" sz="900" dirty="0">
                 <a:solidFill>
                   <a:srgbClr val="A7ADC6"/>
                 </a:solidFill>
@@ -11059,9 +11916,9 @@
                 <a:ea typeface="Inter" pitchFamily="34" charset="-122"/>
                 <a:cs typeface="Inter" pitchFamily="34" charset="-120"/>
               </a:rPr>
-              <a:t>discover portfolios</a:t>
-            </a:r>
-            <a:endParaRPr lang="en-US" sz="1000" dirty="0"/>
+              <a:t>CV edit form</a:t>
+            </a:r>
+            <a:endParaRPr lang="en-US" sz="900" dirty="0"/>
           </a:p>
         </p:txBody>
       </p:sp>
@@ -11073,24 +11930,24 @@
         </p:nvSpPr>
         <p:spPr>
           <a:xfrm>
-            <a:off x="777240" y="3008376"/>
-            <a:ext cx="2103120" cy="201168"/>
-          </a:xfrm>
-          <a:prstGeom prst="rect">
-            <a:avLst/>
-          </a:prstGeom>
-          <a:noFill/>
-          <a:ln/>
-        </p:spPr>
-        <p:txBody>
-          <a:bodyPr wrap="square" lIns="0" tIns="0" rIns="0" bIns="0" rtlCol="0" anchor="ctr"/>
-          <a:lstStyle/>
-          <a:p>
-            <a:pPr indent="0" marL="0">
-              <a:buNone/>
-            </a:pPr>
-            <a:r>
-              <a:rPr lang="en-US" sz="1050" b="1" dirty="0">
+            <a:off x="685800" y="2871216"/>
+            <a:ext cx="2377440" cy="155448"/>
+          </a:xfrm>
+          <a:prstGeom prst="rect">
+            <a:avLst/>
+          </a:prstGeom>
+          <a:noFill/>
+          <a:ln/>
+        </p:spPr>
+        <p:txBody>
+          <a:bodyPr wrap="square" lIns="0" tIns="0" rIns="0" bIns="0" rtlCol="0" anchor="ctr"/>
+          <a:lstStyle/>
+          <a:p>
+            <a:pPr indent="0" marL="0">
+              <a:buNone/>
+            </a:pPr>
+            <a:r>
+              <a:rPr lang="en-US" sz="950" b="1" dirty="0">
                 <a:solidFill>
                   <a:srgbClr val="C0C1FF"/>
                 </a:solidFill>
@@ -11098,9 +11955,9 @@
                 <a:ea typeface="Courier New" pitchFamily="34" charset="-122"/>
                 <a:cs typeface="Courier New" pitchFamily="34" charset="-120"/>
               </a:rPr>
-              <a:t>UserPage.tsx</a:t>
-            </a:r>
-            <a:endParaRPr lang="en-US" sz="1050" dirty="0"/>
+              <a:t>pages/HomePage</a:t>
+            </a:r>
+            <a:endParaRPr lang="en-US" sz="950" dirty="0"/>
           </a:p>
         </p:txBody>
       </p:sp>
@@ -11112,24 +11969,24 @@
         </p:nvSpPr>
         <p:spPr>
           <a:xfrm>
-            <a:off x="2880360" y="3008376"/>
-            <a:ext cx="2194560" cy="201168"/>
-          </a:xfrm>
-          <a:prstGeom prst="rect">
-            <a:avLst/>
-          </a:prstGeom>
-          <a:noFill/>
-          <a:ln/>
-        </p:spPr>
-        <p:txBody>
-          <a:bodyPr wrap="square" lIns="0" tIns="0" rIns="0" bIns="0" rtlCol="0" anchor="ctr"/>
-          <a:lstStyle/>
-          <a:p>
-            <a:pPr indent="0" marL="0">
-              <a:buNone/>
-            </a:pPr>
-            <a:r>
-              <a:rPr lang="en-US" sz="1000" dirty="0">
+            <a:off x="3063240" y="2871216"/>
+            <a:ext cx="2011680" cy="155448"/>
+          </a:xfrm>
+          <a:prstGeom prst="rect">
+            <a:avLst/>
+          </a:prstGeom>
+          <a:noFill/>
+          <a:ln/>
+        </p:spPr>
+        <p:txBody>
+          <a:bodyPr wrap="square" lIns="0" tIns="0" rIns="0" bIns="0" rtlCol="0" anchor="ctr"/>
+          <a:lstStyle/>
+          <a:p>
+            <a:pPr indent="0" marL="0">
+              <a:buNone/>
+            </a:pPr>
+            <a:r>
+              <a:rPr lang="en-US" sz="900" dirty="0">
                 <a:solidFill>
                   <a:srgbClr val="A7ADC6"/>
                 </a:solidFill>
@@ -11137,9 +11994,9 @@
                 <a:ea typeface="Inter" pitchFamily="34" charset="-122"/>
                 <a:cs typeface="Inter" pitchFamily="34" charset="-120"/>
               </a:rPr>
-              <a:t>portfolio (read / edit)</a:t>
-            </a:r>
-            <a:endParaRPr lang="en-US" sz="1000" dirty="0"/>
+              <a:t>discover portfolios</a:t>
+            </a:r>
+            <a:endParaRPr lang="en-US" sz="900" dirty="0"/>
           </a:p>
         </p:txBody>
       </p:sp>
@@ -11151,24 +12008,24 @@
         </p:nvSpPr>
         <p:spPr>
           <a:xfrm>
-            <a:off x="777240" y="3209544"/>
-            <a:ext cx="2103120" cy="201168"/>
-          </a:xfrm>
-          <a:prstGeom prst="rect">
-            <a:avLst/>
-          </a:prstGeom>
-          <a:noFill/>
-          <a:ln/>
-        </p:spPr>
-        <p:txBody>
-          <a:bodyPr wrap="square" lIns="0" tIns="0" rIns="0" bIns="0" rtlCol="0" anchor="ctr"/>
-          <a:lstStyle/>
-          <a:p>
-            <a:pPr indent="0" marL="0">
-              <a:buNone/>
-            </a:pPr>
-            <a:r>
-              <a:rPr lang="en-US" sz="1050" b="1" dirty="0">
+            <a:off x="685800" y="3026664"/>
+            <a:ext cx="2377440" cy="155448"/>
+          </a:xfrm>
+          <a:prstGeom prst="rect">
+            <a:avLst/>
+          </a:prstGeom>
+          <a:noFill/>
+          <a:ln/>
+        </p:spPr>
+        <p:txBody>
+          <a:bodyPr wrap="square" lIns="0" tIns="0" rIns="0" bIns="0" rtlCol="0" anchor="ctr"/>
+          <a:lstStyle/>
+          <a:p>
+            <a:pPr indent="0" marL="0">
+              <a:buNone/>
+            </a:pPr>
+            <a:r>
+              <a:rPr lang="en-US" sz="950" b="1" dirty="0">
                 <a:solidFill>
                   <a:srgbClr val="C0C1FF"/>
                 </a:solidFill>
@@ -11176,9 +12033,9 @@
                 <a:ea typeface="Courier New" pitchFamily="34" charset="-122"/>
                 <a:cs typeface="Courier New" pitchFamily="34" charset="-120"/>
               </a:rPr>
-              <a:t>CvPage.tsx</a:t>
-            </a:r>
-            <a:endParaRPr lang="en-US" sz="1050" dirty="0"/>
+              <a:t>pages/UserPage</a:t>
+            </a:r>
+            <a:endParaRPr lang="en-US" sz="950" dirty="0"/>
           </a:p>
         </p:txBody>
       </p:sp>
@@ -11190,24 +12047,24 @@
         </p:nvSpPr>
         <p:spPr>
           <a:xfrm>
-            <a:off x="2880360" y="3209544"/>
-            <a:ext cx="2194560" cy="201168"/>
-          </a:xfrm>
-          <a:prstGeom prst="rect">
-            <a:avLst/>
-          </a:prstGeom>
-          <a:noFill/>
-          <a:ln/>
-        </p:spPr>
-        <p:txBody>
-          <a:bodyPr wrap="square" lIns="0" tIns="0" rIns="0" bIns="0" rtlCol="0" anchor="ctr"/>
-          <a:lstStyle/>
-          <a:p>
-            <a:pPr indent="0" marL="0">
-              <a:buNone/>
-            </a:pPr>
-            <a:r>
-              <a:rPr lang="en-US" sz="1000" dirty="0">
+            <a:off x="3063240" y="3026664"/>
+            <a:ext cx="2011680" cy="155448"/>
+          </a:xfrm>
+          <a:prstGeom prst="rect">
+            <a:avLst/>
+          </a:prstGeom>
+          <a:noFill/>
+          <a:ln/>
+        </p:spPr>
+        <p:txBody>
+          <a:bodyPr wrap="square" lIns="0" tIns="0" rIns="0" bIns="0" rtlCol="0" anchor="ctr"/>
+          <a:lstStyle/>
+          <a:p>
+            <a:pPr indent="0" marL="0">
+              <a:buNone/>
+            </a:pPr>
+            <a:r>
+              <a:rPr lang="en-US" sz="900" dirty="0">
                 <a:solidFill>
                   <a:srgbClr val="A7ADC6"/>
                 </a:solidFill>
@@ -11215,9 +12072,9 @@
                 <a:ea typeface="Inter" pitchFamily="34" charset="-122"/>
                 <a:cs typeface="Inter" pitchFamily="34" charset="-120"/>
               </a:rPr>
-              <a:t>CV (read / edit)</a:t>
-            </a:r>
-            <a:endParaRPr lang="en-US" sz="1000" dirty="0"/>
+              <a:t>portfolio (read / edit)</a:t>
+            </a:r>
+            <a:endParaRPr lang="en-US" sz="900" dirty="0"/>
           </a:p>
         </p:txBody>
       </p:sp>
@@ -11229,24 +12086,24 @@
         </p:nvSpPr>
         <p:spPr>
           <a:xfrm>
-            <a:off x="777240" y="3410712"/>
-            <a:ext cx="2103120" cy="201168"/>
-          </a:xfrm>
-          <a:prstGeom prst="rect">
-            <a:avLst/>
-          </a:prstGeom>
-          <a:noFill/>
-          <a:ln/>
-        </p:spPr>
-        <p:txBody>
-          <a:bodyPr wrap="square" lIns="0" tIns="0" rIns="0" bIns="0" rtlCol="0" anchor="ctr"/>
-          <a:lstStyle/>
-          <a:p>
-            <a:pPr indent="0" marL="0">
-              <a:buNone/>
-            </a:pPr>
-            <a:r>
-              <a:rPr lang="en-US" sz="1050" b="1" dirty="0">
+            <a:off x="685800" y="3182112"/>
+            <a:ext cx="2377440" cy="155448"/>
+          </a:xfrm>
+          <a:prstGeom prst="rect">
+            <a:avLst/>
+          </a:prstGeom>
+          <a:noFill/>
+          <a:ln/>
+        </p:spPr>
+        <p:txBody>
+          <a:bodyPr wrap="square" lIns="0" tIns="0" rIns="0" bIns="0" rtlCol="0" anchor="ctr"/>
+          <a:lstStyle/>
+          <a:p>
+            <a:pPr indent="0" marL="0">
+              <a:buNone/>
+            </a:pPr>
+            <a:r>
+              <a:rPr lang="en-US" sz="950" b="1" dirty="0">
                 <a:solidFill>
                   <a:srgbClr val="C0C1FF"/>
                 </a:solidFill>
@@ -11254,9 +12111,9 @@
                 <a:ea typeface="Courier New" pitchFamily="34" charset="-122"/>
                 <a:cs typeface="Courier New" pitchFamily="34" charset="-120"/>
               </a:rPr>
-              <a:t>ProjectCard.tsx</a:t>
-            </a:r>
-            <a:endParaRPr lang="en-US" sz="1050" dirty="0"/>
+              <a:t>pages/CvPage</a:t>
+            </a:r>
+            <a:endParaRPr lang="en-US" sz="950" dirty="0"/>
           </a:p>
         </p:txBody>
       </p:sp>
@@ -11268,24 +12125,24 @@
         </p:nvSpPr>
         <p:spPr>
           <a:xfrm>
-            <a:off x="2880360" y="3410712"/>
-            <a:ext cx="2194560" cy="201168"/>
-          </a:xfrm>
-          <a:prstGeom prst="rect">
-            <a:avLst/>
-          </a:prstGeom>
-          <a:noFill/>
-          <a:ln/>
-        </p:spPr>
-        <p:txBody>
-          <a:bodyPr wrap="square" lIns="0" tIns="0" rIns="0" bIns="0" rtlCol="0" anchor="ctr"/>
-          <a:lstStyle/>
-          <a:p>
-            <a:pPr indent="0" marL="0">
-              <a:buNone/>
-            </a:pPr>
-            <a:r>
-              <a:rPr lang="en-US" sz="1000" dirty="0">
+            <a:off x="3063240" y="3182112"/>
+            <a:ext cx="2011680" cy="155448"/>
+          </a:xfrm>
+          <a:prstGeom prst="rect">
+            <a:avLst/>
+          </a:prstGeom>
+          <a:noFill/>
+          <a:ln/>
+        </p:spPr>
+        <p:txBody>
+          <a:bodyPr wrap="square" lIns="0" tIns="0" rIns="0" bIns="0" rtlCol="0" anchor="ctr"/>
+          <a:lstStyle/>
+          <a:p>
+            <a:pPr indent="0" marL="0">
+              <a:buNone/>
+            </a:pPr>
+            <a:r>
+              <a:rPr lang="en-US" sz="900" dirty="0">
                 <a:solidFill>
                   <a:srgbClr val="A7ADC6"/>
                 </a:solidFill>
@@ -11293,9 +12150,9 @@
                 <a:ea typeface="Inter" pitchFamily="34" charset="-122"/>
                 <a:cs typeface="Inter" pitchFamily="34" charset="-120"/>
               </a:rPr>
-              <a:t>single repo card</a:t>
-            </a:r>
-            <a:endParaRPr lang="en-US" sz="1000" dirty="0"/>
+              <a:t>CV (read / edit)</a:t>
+            </a:r>
+            <a:endParaRPr lang="en-US" sz="900" dirty="0"/>
           </a:p>
         </p:txBody>
       </p:sp>
@@ -11307,24 +12164,24 @@
         </p:nvSpPr>
         <p:spPr>
           <a:xfrm>
-            <a:off x="777240" y="3611880"/>
-            <a:ext cx="2103120" cy="201168"/>
-          </a:xfrm>
-          <a:prstGeom prst="rect">
-            <a:avLst/>
-          </a:prstGeom>
-          <a:noFill/>
-          <a:ln/>
-        </p:spPr>
-        <p:txBody>
-          <a:bodyPr wrap="square" lIns="0" tIns="0" rIns="0" bIns="0" rtlCol="0" anchor="ctr"/>
-          <a:lstStyle/>
-          <a:p>
-            <a:pPr indent="0" marL="0">
-              <a:buNone/>
-            </a:pPr>
-            <a:r>
-              <a:rPr lang="en-US" sz="1050" b="1" dirty="0">
+            <a:off x="685800" y="3337560"/>
+            <a:ext cx="2377440" cy="155448"/>
+          </a:xfrm>
+          <a:prstGeom prst="rect">
+            <a:avLst/>
+          </a:prstGeom>
+          <a:noFill/>
+          <a:ln/>
+        </p:spPr>
+        <p:txBody>
+          <a:bodyPr wrap="square" lIns="0" tIns="0" rIns="0" bIns="0" rtlCol="0" anchor="ctr"/>
+          <a:lstStyle/>
+          <a:p>
+            <a:pPr indent="0" marL="0">
+              <a:buNone/>
+            </a:pPr>
+            <a:r>
+              <a:rPr lang="en-US" sz="950" b="1" dirty="0">
                 <a:solidFill>
                   <a:srgbClr val="C0C1FF"/>
                 </a:solidFill>
@@ -11332,9 +12189,9 @@
                 <a:ea typeface="Courier New" pitchFamily="34" charset="-122"/>
                 <a:cs typeface="Courier New" pitchFamily="34" charset="-120"/>
               </a:rPr>
-              <a:t>lib/supabase.ts</a:t>
-            </a:r>
-            <a:endParaRPr lang="en-US" sz="1050" dirty="0"/>
+              <a:t>pages/MyPagesPage</a:t>
+            </a:r>
+            <a:endParaRPr lang="en-US" sz="950" dirty="0"/>
           </a:p>
         </p:txBody>
       </p:sp>
@@ -11346,24 +12203,24 @@
         </p:nvSpPr>
         <p:spPr>
           <a:xfrm>
-            <a:off x="2880360" y="3611880"/>
-            <a:ext cx="2194560" cy="201168"/>
-          </a:xfrm>
-          <a:prstGeom prst="rect">
-            <a:avLst/>
-          </a:prstGeom>
-          <a:noFill/>
-          <a:ln/>
-        </p:spPr>
-        <p:txBody>
-          <a:bodyPr wrap="square" lIns="0" tIns="0" rIns="0" bIns="0" rtlCol="0" anchor="ctr"/>
-          <a:lstStyle/>
-          <a:p>
-            <a:pPr indent="0" marL="0">
-              <a:buNone/>
-            </a:pPr>
-            <a:r>
-              <a:rPr lang="en-US" sz="1000" dirty="0">
+            <a:off x="3063240" y="3337560"/>
+            <a:ext cx="2011680" cy="155448"/>
+          </a:xfrm>
+          <a:prstGeom prst="rect">
+            <a:avLst/>
+          </a:prstGeom>
+          <a:noFill/>
+          <a:ln/>
+        </p:spPr>
+        <p:txBody>
+          <a:bodyPr wrap="square" lIns="0" tIns="0" rIns="0" bIns="0" rtlCol="0" anchor="ctr"/>
+          <a:lstStyle/>
+          <a:p>
+            <a:pPr indent="0" marL="0">
+              <a:buNone/>
+            </a:pPr>
+            <a:r>
+              <a:rPr lang="en-US" sz="900" dirty="0">
                 <a:solidFill>
                   <a:srgbClr val="A7ADC6"/>
                 </a:solidFill>
@@ -11371,9 +12228,9 @@
                 <a:ea typeface="Inter" pitchFamily="34" charset="-122"/>
                 <a:cs typeface="Inter" pitchFamily="34" charset="-120"/>
               </a:rPr>
-              <a:t>client + auth</a:t>
-            </a:r>
-            <a:endParaRPr lang="en-US" sz="1000" dirty="0"/>
+              <a:t>owner dashboard</a:t>
+            </a:r>
+            <a:endParaRPr lang="en-US" sz="900" dirty="0"/>
           </a:p>
         </p:txBody>
       </p:sp>
@@ -11385,24 +12242,24 @@
         </p:nvSpPr>
         <p:spPr>
           <a:xfrm>
-            <a:off x="777240" y="3813048"/>
-            <a:ext cx="2103120" cy="201168"/>
-          </a:xfrm>
-          <a:prstGeom prst="rect">
-            <a:avLst/>
-          </a:prstGeom>
-          <a:noFill/>
-          <a:ln/>
-        </p:spPr>
-        <p:txBody>
-          <a:bodyPr wrap="square" lIns="0" tIns="0" rIns="0" bIns="0" rtlCol="0" anchor="ctr"/>
-          <a:lstStyle/>
-          <a:p>
-            <a:pPr indent="0" marL="0">
-              <a:buNone/>
-            </a:pPr>
-            <a:r>
-              <a:rPr lang="en-US" sz="1050" b="1" dirty="0">
+            <a:off x="685800" y="3493008"/>
+            <a:ext cx="2377440" cy="155448"/>
+          </a:xfrm>
+          <a:prstGeom prst="rect">
+            <a:avLst/>
+          </a:prstGeom>
+          <a:noFill/>
+          <a:ln/>
+        </p:spPr>
+        <p:txBody>
+          <a:bodyPr wrap="square" lIns="0" tIns="0" rIns="0" bIns="0" rtlCol="0" anchor="ctr"/>
+          <a:lstStyle/>
+          <a:p>
+            <a:pPr indent="0" marL="0">
+              <a:buNone/>
+            </a:pPr>
+            <a:r>
+              <a:rPr lang="en-US" sz="950" b="1" dirty="0">
                 <a:solidFill>
                   <a:srgbClr val="C0C1FF"/>
                 </a:solidFill>
@@ -11410,9 +12267,9 @@
                 <a:ea typeface="Courier New" pitchFamily="34" charset="-122"/>
                 <a:cs typeface="Courier New" pitchFamily="34" charset="-120"/>
               </a:rPr>
-              <a:t>lib/portfolio.ts</a:t>
-            </a:r>
-            <a:endParaRPr lang="en-US" sz="1050" dirty="0"/>
+              <a:t>components/ProjectCard</a:t>
+            </a:r>
+            <a:endParaRPr lang="en-US" sz="950" dirty="0"/>
           </a:p>
         </p:txBody>
       </p:sp>
@@ -11424,24 +12281,24 @@
         </p:nvSpPr>
         <p:spPr>
           <a:xfrm>
-            <a:off x="2880360" y="3813048"/>
-            <a:ext cx="2194560" cy="201168"/>
-          </a:xfrm>
-          <a:prstGeom prst="rect">
-            <a:avLst/>
-          </a:prstGeom>
-          <a:noFill/>
-          <a:ln/>
-        </p:spPr>
-        <p:txBody>
-          <a:bodyPr wrap="square" lIns="0" tIns="0" rIns="0" bIns="0" rtlCol="0" anchor="ctr"/>
-          <a:lstStyle/>
-          <a:p>
-            <a:pPr indent="0" marL="0">
-              <a:buNone/>
-            </a:pPr>
-            <a:r>
-              <a:rPr lang="en-US" sz="1000" dirty="0">
+            <a:off x="3063240" y="3493008"/>
+            <a:ext cx="2011680" cy="155448"/>
+          </a:xfrm>
+          <a:prstGeom prst="rect">
+            <a:avLst/>
+          </a:prstGeom>
+          <a:noFill/>
+          <a:ln/>
+        </p:spPr>
+        <p:txBody>
+          <a:bodyPr wrap="square" lIns="0" tIns="0" rIns="0" bIns="0" rtlCol="0" anchor="ctr"/>
+          <a:lstStyle/>
+          <a:p>
+            <a:pPr indent="0" marL="0">
+              <a:buNone/>
+            </a:pPr>
+            <a:r>
+              <a:rPr lang="en-US" sz="900" dirty="0">
                 <a:solidFill>
                   <a:srgbClr val="A7ADC6"/>
                 </a:solidFill>
@@ -11449,9 +12306,9 @@
                 <a:ea typeface="Inter" pitchFamily="34" charset="-122"/>
                 <a:cs typeface="Inter" pitchFamily="34" charset="-120"/>
               </a:rPr>
-              <a:t>profiles · folders · items</a:t>
-            </a:r>
-            <a:endParaRPr lang="en-US" sz="1000" dirty="0"/>
+              <a:t>single repo card</a:t>
+            </a:r>
+            <a:endParaRPr lang="en-US" sz="900" dirty="0"/>
           </a:p>
         </p:txBody>
       </p:sp>
@@ -11463,24 +12320,24 @@
         </p:nvSpPr>
         <p:spPr>
           <a:xfrm>
-            <a:off x="777240" y="4014216"/>
-            <a:ext cx="2103120" cy="201168"/>
-          </a:xfrm>
-          <a:prstGeom prst="rect">
-            <a:avLst/>
-          </a:prstGeom>
-          <a:noFill/>
-          <a:ln/>
-        </p:spPr>
-        <p:txBody>
-          <a:bodyPr wrap="square" lIns="0" tIns="0" rIns="0" bIns="0" rtlCol="0" anchor="ctr"/>
-          <a:lstStyle/>
-          <a:p>
-            <a:pPr indent="0" marL="0">
-              <a:buNone/>
-            </a:pPr>
-            <a:r>
-              <a:rPr lang="en-US" sz="1050" b="1" dirty="0">
+            <a:off x="685800" y="3648456"/>
+            <a:ext cx="2377440" cy="155448"/>
+          </a:xfrm>
+          <a:prstGeom prst="rect">
+            <a:avLst/>
+          </a:prstGeom>
+          <a:noFill/>
+          <a:ln/>
+        </p:spPr>
+        <p:txBody>
+          <a:bodyPr wrap="square" lIns="0" tIns="0" rIns="0" bIns="0" rtlCol="0" anchor="ctr"/>
+          <a:lstStyle/>
+          <a:p>
+            <a:pPr indent="0" marL="0">
+              <a:buNone/>
+            </a:pPr>
+            <a:r>
+              <a:rPr lang="en-US" sz="950" b="1" dirty="0">
                 <a:solidFill>
                   <a:srgbClr val="C0C1FF"/>
                 </a:solidFill>
@@ -11488,9 +12345,9 @@
                 <a:ea typeface="Courier New" pitchFamily="34" charset="-122"/>
                 <a:cs typeface="Courier New" pitchFamily="34" charset="-120"/>
               </a:rPr>
-              <a:t>lib/github.ts</a:t>
-            </a:r>
-            <a:endParaRPr lang="en-US" sz="1050" dirty="0"/>
+              <a:t>components/UserTabs</a:t>
+            </a:r>
+            <a:endParaRPr lang="en-US" sz="950" dirty="0"/>
           </a:p>
         </p:txBody>
       </p:sp>
@@ -11502,24 +12359,24 @@
         </p:nvSpPr>
         <p:spPr>
           <a:xfrm>
-            <a:off x="2880360" y="4014216"/>
-            <a:ext cx="2194560" cy="201168"/>
-          </a:xfrm>
-          <a:prstGeom prst="rect">
-            <a:avLst/>
-          </a:prstGeom>
-          <a:noFill/>
-          <a:ln/>
-        </p:spPr>
-        <p:txBody>
-          <a:bodyPr wrap="square" lIns="0" tIns="0" rIns="0" bIns="0" rtlCol="0" anchor="ctr"/>
-          <a:lstStyle/>
-          <a:p>
-            <a:pPr indent="0" marL="0">
-              <a:buNone/>
-            </a:pPr>
-            <a:r>
-              <a:rPr lang="en-US" sz="1000" dirty="0">
+            <a:off x="3063240" y="3648456"/>
+            <a:ext cx="2011680" cy="155448"/>
+          </a:xfrm>
+          <a:prstGeom prst="rect">
+            <a:avLst/>
+          </a:prstGeom>
+          <a:noFill/>
+          <a:ln/>
+        </p:spPr>
+        <p:txBody>
+          <a:bodyPr wrap="square" lIns="0" tIns="0" rIns="0" bIns="0" rtlCol="0" anchor="ctr"/>
+          <a:lstStyle/>
+          <a:p>
+            <a:pPr indent="0" marL="0">
+              <a:buNone/>
+            </a:pPr>
+            <a:r>
+              <a:rPr lang="en-US" sz="900" dirty="0">
                 <a:solidFill>
                   <a:srgbClr val="A7ADC6"/>
                 </a:solidFill>
@@ -11527,9 +12384,9 @@
                 <a:ea typeface="Inter" pitchFamily="34" charset="-122"/>
                 <a:cs typeface="Inter" pitchFamily="34" charset="-120"/>
               </a:rPr>
-              <a:t>API calls + YAML merge</a:t>
-            </a:r>
-            <a:endParaRPr lang="en-US" sz="1000" dirty="0"/>
+              <a:t>nav between user's pages</a:t>
+            </a:r>
+            <a:endParaRPr lang="en-US" sz="900" dirty="0"/>
           </a:p>
         </p:txBody>
       </p:sp>
@@ -11541,24 +12398,24 @@
         </p:nvSpPr>
         <p:spPr>
           <a:xfrm>
-            <a:off x="777240" y="4215384"/>
-            <a:ext cx="2103120" cy="201168"/>
-          </a:xfrm>
-          <a:prstGeom prst="rect">
-            <a:avLst/>
-          </a:prstGeom>
-          <a:noFill/>
-          <a:ln/>
-        </p:spPr>
-        <p:txBody>
-          <a:bodyPr wrap="square" lIns="0" tIns="0" rIns="0" bIns="0" rtlCol="0" anchor="ctr"/>
-          <a:lstStyle/>
-          <a:p>
-            <a:pPr indent="0" marL="0">
-              <a:buNone/>
-            </a:pPr>
-            <a:r>
-              <a:rPr lang="en-US" sz="1050" b="1" dirty="0">
+            <a:off x="685800" y="3803904"/>
+            <a:ext cx="2377440" cy="155448"/>
+          </a:xfrm>
+          <a:prstGeom prst="rect">
+            <a:avLst/>
+          </a:prstGeom>
+          <a:noFill/>
+          <a:ln/>
+        </p:spPr>
+        <p:txBody>
+          <a:bodyPr wrap="square" lIns="0" tIns="0" rIns="0" bIns="0" rtlCol="0" anchor="ctr"/>
+          <a:lstStyle/>
+          <a:p>
+            <a:pPr indent="0" marL="0">
+              <a:buNone/>
+            </a:pPr>
+            <a:r>
+              <a:rPr lang="en-US" sz="950" b="1" dirty="0">
                 <a:solidFill>
                   <a:srgbClr val="C0C1FF"/>
                 </a:solidFill>
@@ -11566,9 +12423,9 @@
                 <a:ea typeface="Courier New" pitchFamily="34" charset="-122"/>
                 <a:cs typeface="Courier New" pitchFamily="34" charset="-120"/>
               </a:rPr>
-              <a:t>lib/cv.ts</a:t>
-            </a:r>
-            <a:endParaRPr lang="en-US" sz="1050" dirty="0"/>
+              <a:t>lib/supabase.ts</a:t>
+            </a:r>
+            <a:endParaRPr lang="en-US" sz="950" dirty="0"/>
           </a:p>
         </p:txBody>
       </p:sp>
@@ -11580,24 +12437,24 @@
         </p:nvSpPr>
         <p:spPr>
           <a:xfrm>
-            <a:off x="2880360" y="4215384"/>
-            <a:ext cx="2194560" cy="201168"/>
-          </a:xfrm>
-          <a:prstGeom prst="rect">
-            <a:avLst/>
-          </a:prstGeom>
-          <a:noFill/>
-          <a:ln/>
-        </p:spPr>
-        <p:txBody>
-          <a:bodyPr wrap="square" lIns="0" tIns="0" rIns="0" bIns="0" rtlCol="0" anchor="ctr"/>
-          <a:lstStyle/>
-          <a:p>
-            <a:pPr indent="0" marL="0">
-              <a:buNone/>
-            </a:pPr>
-            <a:r>
-              <a:rPr lang="en-US" sz="1000" dirty="0">
+            <a:off x="3063240" y="3803904"/>
+            <a:ext cx="2011680" cy="155448"/>
+          </a:xfrm>
+          <a:prstGeom prst="rect">
+            <a:avLst/>
+          </a:prstGeom>
+          <a:noFill/>
+          <a:ln/>
+        </p:spPr>
+        <p:txBody>
+          <a:bodyPr wrap="square" lIns="0" tIns="0" rIns="0" bIns="0" rtlCol="0" anchor="ctr"/>
+          <a:lstStyle/>
+          <a:p>
+            <a:pPr indent="0" marL="0">
+              <a:buNone/>
+            </a:pPr>
+            <a:r>
+              <a:rPr lang="en-US" sz="900" dirty="0">
                 <a:solidFill>
                   <a:srgbClr val="A7ADC6"/>
                 </a:solidFill>
@@ -11605,9 +12462,9 @@
                 <a:ea typeface="Inter" pitchFamily="34" charset="-122"/>
                 <a:cs typeface="Inter" pitchFamily="34" charset="-120"/>
               </a:rPr>
-              <a:t>CV read / write</a:t>
-            </a:r>
-            <a:endParaRPr lang="en-US" sz="1000" dirty="0"/>
+              <a:t>client + auth</a:t>
+            </a:r>
+            <a:endParaRPr lang="en-US" sz="900" dirty="0"/>
           </a:p>
         </p:txBody>
       </p:sp>
@@ -11619,24 +12476,24 @@
         </p:nvSpPr>
         <p:spPr>
           <a:xfrm>
-            <a:off x="777240" y="4416552"/>
-            <a:ext cx="2103120" cy="201168"/>
-          </a:xfrm>
-          <a:prstGeom prst="rect">
-            <a:avLst/>
-          </a:prstGeom>
-          <a:noFill/>
-          <a:ln/>
-        </p:spPr>
-        <p:txBody>
-          <a:bodyPr wrap="square" lIns="0" tIns="0" rIns="0" bIns="0" rtlCol="0" anchor="ctr"/>
-          <a:lstStyle/>
-          <a:p>
-            <a:pPr indent="0" marL="0">
-              <a:buNone/>
-            </a:pPr>
-            <a:r>
-              <a:rPr lang="en-US" sz="1050" b="1" dirty="0">
+            <a:off x="685800" y="3959352"/>
+            <a:ext cx="2377440" cy="155448"/>
+          </a:xfrm>
+          <a:prstGeom prst="rect">
+            <a:avLst/>
+          </a:prstGeom>
+          <a:noFill/>
+          <a:ln/>
+        </p:spPr>
+        <p:txBody>
+          <a:bodyPr wrap="square" lIns="0" tIns="0" rIns="0" bIns="0" rtlCol="0" anchor="ctr"/>
+          <a:lstStyle/>
+          <a:p>
+            <a:pPr indent="0" marL="0">
+              <a:buNone/>
+            </a:pPr>
+            <a:r>
+              <a:rPr lang="en-US" sz="950" b="1" dirty="0">
                 <a:solidFill>
                   <a:srgbClr val="C0C1FF"/>
                 </a:solidFill>
@@ -11644,9 +12501,9 @@
                 <a:ea typeface="Courier New" pitchFamily="34" charset="-122"/>
                 <a:cs typeface="Courier New" pitchFamily="34" charset="-120"/>
               </a:rPr>
-              <a:t>lib/pageData.ts</a:t>
-            </a:r>
-            <a:endParaRPr lang="en-US" sz="1050" dirty="0"/>
+              <a:t>lib/portfolio.ts</a:t>
+            </a:r>
+            <a:endParaRPr lang="en-US" sz="950" dirty="0"/>
           </a:p>
         </p:txBody>
       </p:sp>
@@ -11658,24 +12515,24 @@
         </p:nvSpPr>
         <p:spPr>
           <a:xfrm>
-            <a:off x="2880360" y="4416552"/>
-            <a:ext cx="2194560" cy="201168"/>
-          </a:xfrm>
-          <a:prstGeom prst="rect">
-            <a:avLst/>
-          </a:prstGeom>
-          <a:noFill/>
-          <a:ln/>
-        </p:spPr>
-        <p:txBody>
-          <a:bodyPr wrap="square" lIns="0" tIns="0" rIns="0" bIns="0" rtlCol="0" anchor="ctr"/>
-          <a:lstStyle/>
-          <a:p>
-            <a:pPr indent="0" marL="0">
-              <a:buNone/>
-            </a:pPr>
-            <a:r>
-              <a:rPr lang="en-US" sz="1000" dirty="0">
+            <a:off x="3063240" y="3959352"/>
+            <a:ext cx="2011680" cy="155448"/>
+          </a:xfrm>
+          <a:prstGeom prst="rect">
+            <a:avLst/>
+          </a:prstGeom>
+          <a:noFill/>
+          <a:ln/>
+        </p:spPr>
+        <p:txBody>
+          <a:bodyPr wrap="square" lIns="0" tIns="0" rIns="0" bIns="0" rtlCol="0" anchor="ctr"/>
+          <a:lstStyle/>
+          <a:p>
+            <a:pPr indent="0" marL="0">
+              <a:buNone/>
+            </a:pPr>
+            <a:r>
+              <a:rPr lang="en-US" sz="900" dirty="0">
                 <a:solidFill>
                   <a:srgbClr val="A7ADC6"/>
                 </a:solidFill>
@@ -11683,15 +12540,249 @@
                 <a:ea typeface="Inter" pitchFamily="34" charset="-122"/>
                 <a:cs typeface="Inter" pitchFamily="34" charset="-120"/>
               </a:rPr>
+              <a:t>profiles · folders · items</a:t>
+            </a:r>
+            <a:endParaRPr lang="en-US" sz="900" dirty="0"/>
+          </a:p>
+        </p:txBody>
+      </p:sp>
+      <p:sp>
+        <p:nvSpPr>
+          <p:cNvPr id="27" name="Text 25"/>
+          <p:cNvSpPr/>
+          <p:nvPr/>
+        </p:nvSpPr>
+        <p:spPr>
+          <a:xfrm>
+            <a:off x="685800" y="4114800"/>
+            <a:ext cx="2377440" cy="155448"/>
+          </a:xfrm>
+          <a:prstGeom prst="rect">
+            <a:avLst/>
+          </a:prstGeom>
+          <a:noFill/>
+          <a:ln/>
+        </p:spPr>
+        <p:txBody>
+          <a:bodyPr wrap="square" lIns="0" tIns="0" rIns="0" bIns="0" rtlCol="0" anchor="ctr"/>
+          <a:lstStyle/>
+          <a:p>
+            <a:pPr indent="0" marL="0">
+              <a:buNone/>
+            </a:pPr>
+            <a:r>
+              <a:rPr lang="en-US" sz="950" b="1" dirty="0">
+                <a:solidFill>
+                  <a:srgbClr val="C0C1FF"/>
+                </a:solidFill>
+                <a:latin typeface="Courier New" pitchFamily="34" charset="0"/>
+                <a:ea typeface="Courier New" pitchFamily="34" charset="-122"/>
+                <a:cs typeface="Courier New" pitchFamily="34" charset="-120"/>
+              </a:rPr>
+              <a:t>lib/github.ts</a:t>
+            </a:r>
+            <a:endParaRPr lang="en-US" sz="950" dirty="0"/>
+          </a:p>
+        </p:txBody>
+      </p:sp>
+      <p:sp>
+        <p:nvSpPr>
+          <p:cNvPr id="28" name="Text 26"/>
+          <p:cNvSpPr/>
+          <p:nvPr/>
+        </p:nvSpPr>
+        <p:spPr>
+          <a:xfrm>
+            <a:off x="3063240" y="4114800"/>
+            <a:ext cx="2011680" cy="155448"/>
+          </a:xfrm>
+          <a:prstGeom prst="rect">
+            <a:avLst/>
+          </a:prstGeom>
+          <a:noFill/>
+          <a:ln/>
+        </p:spPr>
+        <p:txBody>
+          <a:bodyPr wrap="square" lIns="0" tIns="0" rIns="0" bIns="0" rtlCol="0" anchor="ctr"/>
+          <a:lstStyle/>
+          <a:p>
+            <a:pPr indent="0" marL="0">
+              <a:buNone/>
+            </a:pPr>
+            <a:r>
+              <a:rPr lang="en-US" sz="900" dirty="0">
+                <a:solidFill>
+                  <a:srgbClr val="A7ADC6"/>
+                </a:solidFill>
+                <a:latin typeface="Inter" pitchFamily="34" charset="0"/>
+                <a:ea typeface="Inter" pitchFamily="34" charset="-122"/>
+                <a:cs typeface="Inter" pitchFamily="34" charset="-120"/>
+              </a:rPr>
+              <a:t>API calls + YAML merge</a:t>
+            </a:r>
+            <a:endParaRPr lang="en-US" sz="900" dirty="0"/>
+          </a:p>
+        </p:txBody>
+      </p:sp>
+      <p:sp>
+        <p:nvSpPr>
+          <p:cNvPr id="29" name="Text 27"/>
+          <p:cNvSpPr/>
+          <p:nvPr/>
+        </p:nvSpPr>
+        <p:spPr>
+          <a:xfrm>
+            <a:off x="685800" y="4270248"/>
+            <a:ext cx="2377440" cy="155448"/>
+          </a:xfrm>
+          <a:prstGeom prst="rect">
+            <a:avLst/>
+          </a:prstGeom>
+          <a:noFill/>
+          <a:ln/>
+        </p:spPr>
+        <p:txBody>
+          <a:bodyPr wrap="square" lIns="0" tIns="0" rIns="0" bIns="0" rtlCol="0" anchor="ctr"/>
+          <a:lstStyle/>
+          <a:p>
+            <a:pPr indent="0" marL="0">
+              <a:buNone/>
+            </a:pPr>
+            <a:r>
+              <a:rPr lang="en-US" sz="950" b="1" dirty="0">
+                <a:solidFill>
+                  <a:srgbClr val="C0C1FF"/>
+                </a:solidFill>
+                <a:latin typeface="Courier New" pitchFamily="34" charset="0"/>
+                <a:ea typeface="Courier New" pitchFamily="34" charset="-122"/>
+                <a:cs typeface="Courier New" pitchFamily="34" charset="-120"/>
+              </a:rPr>
+              <a:t>lib/cv.ts</a:t>
+            </a:r>
+            <a:endParaRPr lang="en-US" sz="950" dirty="0"/>
+          </a:p>
+        </p:txBody>
+      </p:sp>
+      <p:sp>
+        <p:nvSpPr>
+          <p:cNvPr id="30" name="Text 28"/>
+          <p:cNvSpPr/>
+          <p:nvPr/>
+        </p:nvSpPr>
+        <p:spPr>
+          <a:xfrm>
+            <a:off x="3063240" y="4270248"/>
+            <a:ext cx="2011680" cy="155448"/>
+          </a:xfrm>
+          <a:prstGeom prst="rect">
+            <a:avLst/>
+          </a:prstGeom>
+          <a:noFill/>
+          <a:ln/>
+        </p:spPr>
+        <p:txBody>
+          <a:bodyPr wrap="square" lIns="0" tIns="0" rIns="0" bIns="0" rtlCol="0" anchor="ctr"/>
+          <a:lstStyle/>
+          <a:p>
+            <a:pPr indent="0" marL="0">
+              <a:buNone/>
+            </a:pPr>
+            <a:r>
+              <a:rPr lang="en-US" sz="900" dirty="0">
+                <a:solidFill>
+                  <a:srgbClr val="A7ADC6"/>
+                </a:solidFill>
+                <a:latin typeface="Inter" pitchFamily="34" charset="0"/>
+                <a:ea typeface="Inter" pitchFamily="34" charset="-122"/>
+                <a:cs typeface="Inter" pitchFamily="34" charset="-120"/>
+              </a:rPr>
+              <a:t>CV read / write</a:t>
+            </a:r>
+            <a:endParaRPr lang="en-US" sz="900" dirty="0"/>
+          </a:p>
+        </p:txBody>
+      </p:sp>
+      <p:sp>
+        <p:nvSpPr>
+          <p:cNvPr id="31" name="Text 29"/>
+          <p:cNvSpPr/>
+          <p:nvPr/>
+        </p:nvSpPr>
+        <p:spPr>
+          <a:xfrm>
+            <a:off x="685800" y="4425696"/>
+            <a:ext cx="2377440" cy="155448"/>
+          </a:xfrm>
+          <a:prstGeom prst="rect">
+            <a:avLst/>
+          </a:prstGeom>
+          <a:noFill/>
+          <a:ln/>
+        </p:spPr>
+        <p:txBody>
+          <a:bodyPr wrap="square" lIns="0" tIns="0" rIns="0" bIns="0" rtlCol="0" anchor="ctr"/>
+          <a:lstStyle/>
+          <a:p>
+            <a:pPr indent="0" marL="0">
+              <a:buNone/>
+            </a:pPr>
+            <a:r>
+              <a:rPr lang="en-US" sz="950" b="1" dirty="0">
+                <a:solidFill>
+                  <a:srgbClr val="C0C1FF"/>
+                </a:solidFill>
+                <a:latin typeface="Courier New" pitchFamily="34" charset="0"/>
+                <a:ea typeface="Courier New" pitchFamily="34" charset="-122"/>
+                <a:cs typeface="Courier New" pitchFamily="34" charset="-120"/>
+              </a:rPr>
+              <a:t>lib/pageData.ts</a:t>
+            </a:r>
+            <a:endParaRPr lang="en-US" sz="950" dirty="0"/>
+          </a:p>
+        </p:txBody>
+      </p:sp>
+      <p:sp>
+        <p:nvSpPr>
+          <p:cNvPr id="32" name="Text 30"/>
+          <p:cNvSpPr/>
+          <p:nvPr/>
+        </p:nvSpPr>
+        <p:spPr>
+          <a:xfrm>
+            <a:off x="3063240" y="4425696"/>
+            <a:ext cx="2011680" cy="155448"/>
+          </a:xfrm>
+          <a:prstGeom prst="rect">
+            <a:avLst/>
+          </a:prstGeom>
+          <a:noFill/>
+          <a:ln/>
+        </p:spPr>
+        <p:txBody>
+          <a:bodyPr wrap="square" lIns="0" tIns="0" rIns="0" bIns="0" rtlCol="0" anchor="ctr"/>
+          <a:lstStyle/>
+          <a:p>
+            <a:pPr indent="0" marL="0">
+              <a:buNone/>
+            </a:pPr>
+            <a:r>
+              <a:rPr lang="en-US" sz="900" dirty="0">
+                <a:solidFill>
+                  <a:srgbClr val="A7ADC6"/>
+                </a:solidFill>
+                <a:latin typeface="Inter" pitchFamily="34" charset="0"/>
+                <a:ea typeface="Inter" pitchFamily="34" charset="-122"/>
+                <a:cs typeface="Inter" pitchFamily="34" charset="-120"/>
+              </a:rPr>
               <a:t>request cache</a:t>
             </a:r>
-            <a:endParaRPr lang="en-US" sz="1000" dirty="0"/>
-          </a:p>
-        </p:txBody>
-      </p:sp>
-      <p:sp>
-        <p:nvSpPr>
-          <p:cNvPr id="27" name="Text 25"/>
+            <a:endParaRPr lang="en-US" sz="900" dirty="0"/>
+          </a:p>
+        </p:txBody>
+      </p:sp>
+      <p:sp>
+        <p:nvSpPr>
+          <p:cNvPr id="33" name="Text 31"/>
           <p:cNvSpPr/>
           <p:nvPr/>
         </p:nvSpPr>
@@ -11730,7 +12821,7 @@
       </p:sp>
       <p:sp>
         <p:nvSpPr>
-          <p:cNvPr id="28" name="Shape 26"/>
+          <p:cNvPr id="34" name="Shape 32"/>
           <p:cNvSpPr/>
           <p:nvPr/>
         </p:nvSpPr>
@@ -11755,7 +12846,7 @@
       </p:sp>
       <p:sp>
         <p:nvSpPr>
-          <p:cNvPr id="29" name="Text 27"/>
+          <p:cNvPr id="35" name="Text 33"/>
           <p:cNvSpPr/>
           <p:nvPr/>
         </p:nvSpPr>
@@ -11794,7 +12885,7 @@
       </p:sp>
       <p:sp>
         <p:nvSpPr>
-          <p:cNvPr id="30" name="Text 28"/>
+          <p:cNvPr id="36" name="Text 34"/>
           <p:cNvSpPr/>
           <p:nvPr/>
         </p:nvSpPr>
@@ -11833,7 +12924,7 @@
       </p:sp>
       <p:sp>
         <p:nvSpPr>
-          <p:cNvPr id="31" name="Shape 29"/>
+          <p:cNvPr id="37" name="Shape 35"/>
           <p:cNvSpPr/>
           <p:nvPr/>
         </p:nvSpPr>
@@ -11858,7 +12949,7 @@
       </p:sp>
       <p:sp>
         <p:nvSpPr>
-          <p:cNvPr id="32" name="Text 30"/>
+          <p:cNvPr id="38" name="Text 36"/>
           <p:cNvSpPr/>
           <p:nvPr/>
         </p:nvSpPr>
@@ -11897,7 +12988,7 @@
       </p:sp>
       <p:sp>
         <p:nvSpPr>
-          <p:cNvPr id="33" name="Text 31"/>
+          <p:cNvPr id="39" name="Text 37"/>
           <p:cNvSpPr/>
           <p:nvPr/>
         </p:nvSpPr>
@@ -11936,7 +13027,7 @@
       </p:sp>
       <p:sp>
         <p:nvSpPr>
-          <p:cNvPr id="34" name="Shape 32"/>
+          <p:cNvPr id="40" name="Shape 38"/>
           <p:cNvSpPr/>
           <p:nvPr/>
         </p:nvSpPr>
@@ -11959,7 +13050,7 @@
       </p:sp>
       <p:sp>
         <p:nvSpPr>
-          <p:cNvPr id="35" name="Text 33"/>
+          <p:cNvPr id="41" name="Text 39"/>
           <p:cNvSpPr/>
           <p:nvPr/>
         </p:nvSpPr>
@@ -11998,7 +13089,7 @@
       </p:sp>
       <p:sp>
         <p:nvSpPr>
-          <p:cNvPr id="36" name="Text 34"/>
+          <p:cNvPr id="42" name="Text 40"/>
           <p:cNvSpPr/>
           <p:nvPr/>
         </p:nvSpPr>

</xml_diff>